<commit_message>
Add Colab results, LoRA adapters, and fill the walkthrough deck metrics.
Lock the plain vs fine-tuned comparison and settings.json into results/, store the adapter weights with Git LFS, and regenerate the PowerPoint from those artifacts.

Co-authored-by: Cursor <cursoragent@cursor.com>
</commit_message>
<xml_diff>
--- a/docs/CampusClaim_Notebook_Walkthrough.pptx
+++ b/docs/CampusClaim_Notebook_Walkthrough.pptx
@@ -33,6 +33,7 @@
     <p:sldId id="281" r:id="rId32"/>
     <p:sldId id="282" r:id="rId33"/>
     <p:sldId id="283" r:id="rId34"/>
+    <p:sldId id="284" r:id="rId35"/>
   </p:sldIdLst>
   <p:sldSz cx="12191695" cy="6858000" type="screen4x3"/>
   <p:notesSz cx="6858000" cy="9144000"/>
@@ -3691,7 +3692,7 @@
                 </a:solidFill>
                 <a:latin typeface="Calibri"/>
               </a:rPr>
-              <a:t>10 / 28</a:t>
+              <a:t>10 / 29</a:t>
             </a:r>
           </a:p>
         </p:txBody>
@@ -4033,7 +4034,7 @@
                 </a:solidFill>
                 <a:latin typeface="Calibri"/>
               </a:rPr>
-              <a:t>11 / 28</a:t>
+              <a:t>11 / 29</a:t>
             </a:r>
           </a:p>
         </p:txBody>
@@ -4359,7 +4360,7 @@
                 </a:solidFill>
                 <a:latin typeface="Calibri"/>
               </a:rPr>
-              <a:t>12 / 28</a:t>
+              <a:t>12 / 29</a:t>
             </a:r>
           </a:p>
         </p:txBody>
@@ -4685,7 +4686,7 @@
                 </a:solidFill>
                 <a:latin typeface="Calibri"/>
               </a:rPr>
-              <a:t>13 / 28</a:t>
+              <a:t>13 / 29</a:t>
             </a:r>
           </a:p>
         </p:txBody>
@@ -4839,7 +4840,7 @@
                 </a:solidFill>
                 <a:latin typeface="Calibri"/>
               </a:rPr>
-              <a:t>Vision layers are trained because the task is reading the receipt</a:t>
+              <a:t>Settings locked in results/settings.json from the Colab run</a:t>
             </a:r>
           </a:p>
         </p:txBody>
@@ -4878,7 +4879,7 @@
                 </a:solidFill>
                 <a:latin typeface="Calibri"/>
               </a:rPr>
-              <a:t>FastVisionModel.get_peft_model · r = alpha = 16 · dropout 0 · all-linear targets</a:t>
+              <a:t>Model: unsloth/gemma-4-E2B-it · 4-bit · float32 on T4</a:t>
             </a:r>
           </a:p>
           <a:p>
@@ -4894,7 +4895,7 @@
                 </a:solidFill>
                 <a:latin typeface="Calibri"/>
               </a:rPr>
-              <a:t>finetune_vision_layers = True (and language / attention / MLP)</a:t>
+              <a:t>LoRA rank / alpha = 16 · finetune_vision_layers = True · all-linear targets</a:t>
             </a:r>
           </a:p>
           <a:p>
@@ -4910,7 +4911,7 @@
                 </a:solidFill>
                 <a:latin typeface="Calibri"/>
               </a:rPr>
-              <a:t>SFTTrainer + UnslothVisionDataCollator · processing_class = processor</a:t>
+              <a:t>120 steps ≈ 0.75 epoch over 625 usable train receipts</a:t>
             </a:r>
           </a:p>
           <a:p>
@@ -4926,7 +4927,7 @@
                 </a:solidFill>
                 <a:latin typeface="Calibri"/>
               </a:rPr>
-              <a:t>120 steps ≈ 0.75 epoch over 625 usable train receipts</a:t>
+              <a:t>LR 0.0002 · batch 1 · grad accum 4 · max_length 2048</a:t>
             </a:r>
           </a:p>
           <a:p>
@@ -4942,7 +4943,7 @@
                 </a:solidFill>
                 <a:latin typeface="Calibri"/>
               </a:rPr>
-              <a:t>LR 2e-4 · batch 1 · grad accum 4 · max_length 2048 · adamw_8bit · cosine schedule</a:t>
+              <a:t>MAX_IMAGE_SIDE = 1024 · UnslothVisionDataCollator · processing_class = processor</a:t>
             </a:r>
           </a:p>
           <a:p>
@@ -4958,7 +4959,7 @@
                 </a:solidFill>
                 <a:latin typeface="Calibri"/>
               </a:rPr>
-              <a:t>skip_prepare_dataset=True · remove_unused_columns=False</a:t>
+              <a:t>Adapters saved to adapters/campusclaim_gemma4_lora/</a:t>
             </a:r>
           </a:p>
           <a:p>
@@ -4974,7 +4975,7 @@
                 </a:solidFill>
                 <a:latin typeface="Calibri"/>
               </a:rPr>
-              <a:t>OOM fallbacks: LORA_RANK=8 · finetune_vision_layers=False · MAX_IMAGE_SIDE=800</a:t>
+              <a:t>OOM fallbacks (not used this run): rank 8 · freeze vision · image side 800</a:t>
             </a:r>
           </a:p>
         </p:txBody>
@@ -5043,7 +5044,7 @@
                 </a:solidFill>
                 <a:latin typeface="Calibri"/>
               </a:rPr>
-              <a:t>14 / 28</a:t>
+              <a:t>14 / 29</a:t>
             </a:r>
           </a:p>
         </p:txBody>
@@ -5197,7 +5198,7 @@
                 </a:solidFill>
                 <a:latin typeface="Calibri"/>
               </a:rPr>
-              <a:t>Same receipts · same instruction · same scorers</a:t>
+              <a:t>Same 100 receipts · seed 0 · same instruction</a:t>
             </a:r>
           </a:p>
         </p:txBody>
@@ -5268,7 +5269,7 @@
                 </a:solidFill>
                 <a:latin typeface="Calibri"/>
               </a:rPr>
-              <a:t>Failure table: receipts with any wrong field among company/date/address/total</a:t>
+              <a:t>33 of 100 receipts still had ≥1 wrong field — address exact remains hardest</a:t>
             </a:r>
           </a:p>
           <a:p>
@@ -5284,7 +5285,7 @@
                 </a:solidFill>
                 <a:latin typeface="Calibri"/>
               </a:rPr>
-              <a:t>Show where fine-tuning helped and where it did not — no invented wins</a:t>
+              <a:t>Biggest gains: address exact +19.0 · date exact +11.0 · address token-F1 +7.1</a:t>
             </a:r>
           </a:p>
           <a:p>
@@ -5300,7 +5301,7 @@
                 </a:solidFill>
                 <a:latin typeface="Calibri"/>
               </a:rPr>
-              <a:t>Exact address is strict; always show token-F1 beside it</a:t>
+              <a:t>Valid JSON stayed at 100% for both models</a:t>
             </a:r>
           </a:p>
         </p:txBody>
@@ -5369,7 +5370,7 @@
                 </a:solidFill>
                 <a:latin typeface="Calibri"/>
               </a:rPr>
-              <a:t>15 / 28</a:t>
+              <a:t>15 / 29</a:t>
             </a:r>
           </a:p>
         </p:txBody>
@@ -5507,7 +5508,7 @@
                 </a:solidFill>
                 <a:latin typeface="Georgia"/>
               </a:rPr>
-              <a:t>Metrics slide (fill from results/)</a:t>
+              <a:t>Evidence — plain vs fine-tuned</a:t>
             </a:r>
           </a:p>
           <a:p>
@@ -5523,7 +5524,7 @@
                 </a:solidFill>
                 <a:latin typeface="Calibri"/>
               </a:rPr>
-              <a:t>Numbers come only from comparison.csv after the Colab run — never invent them</a:t>
+              <a:t>Copied from results/comparison.csv · 100 frozen SROIE test receipts</a:t>
             </a:r>
           </a:p>
         </p:txBody>
@@ -5537,8 +5538,8 @@
           <p:nvPr/>
         </p:nvGraphicFramePr>
         <p:xfrm>
-          <a:off x="1097280" y="1554480"/>
-          <a:ext cx="9875520" cy="3840480"/>
+          <a:off x="1097280" y="1417320"/>
+          <a:ext cx="9875520" cy="3657600"/>
         </p:xfrm>
         <a:graphic>
           <a:graphicData uri="http://schemas.openxmlformats.org/drawingml/2006/table">
@@ -5552,7 +5553,7 @@
                 <a:gridCol w="2468880"/>
                 <a:gridCol w="2468880"/>
               </a:tblGrid>
-              <a:tr h="548640">
+              <a:tr h="522514">
                 <a:tc>
                   <a:txBody>
                     <a:bodyPr/>
@@ -5615,7 +5616,7 @@
                   </a:txBody>
                   <a:tcPr>
                     <a:solidFill>
-                      <a:srgbClr val="0F2C3C"/>
+                      <a:srgbClr val="C45C26"/>
                     </a:solidFill>
                   </a:tcPr>
                 </a:tc>
@@ -5642,7 +5643,7 @@
                   </a:tcPr>
                 </a:tc>
               </a:tr>
-              <a:tr h="548640">
+              <a:tr h="522514">
                 <a:tc>
                   <a:txBody>
                     <a:bodyPr/>
@@ -5677,7 +5678,7 @@
                           </a:solidFill>
                           <a:latin typeface="Calibri"/>
                         </a:rPr>
-                        <a:t>—</a:t>
+                        <a:t>100.0%</a:t>
                       </a:r>
                     </a:p>
                   </a:txBody>
@@ -5699,7 +5700,7 @@
                           </a:solidFill>
                           <a:latin typeface="Calibri"/>
                         </a:rPr>
-                        <a:t>—</a:t>
+                        <a:t>100.0%</a:t>
                       </a:r>
                     </a:p>
                   </a:txBody>
@@ -5721,7 +5722,7 @@
                           </a:solidFill>
                           <a:latin typeface="Calibri"/>
                         </a:rPr>
-                        <a:t>—</a:t>
+                        <a:t>0.0</a:t>
                       </a:r>
                     </a:p>
                   </a:txBody>
@@ -5732,7 +5733,7 @@
                   </a:tcPr>
                 </a:tc>
               </a:tr>
-              <a:tr h="548640">
+              <a:tr h="522514">
                 <a:tc>
                   <a:txBody>
                     <a:bodyPr/>
@@ -5767,7 +5768,7 @@
                           </a:solidFill>
                           <a:latin typeface="Calibri"/>
                         </a:rPr>
-                        <a:t>—</a:t>
+                        <a:t>79.0%</a:t>
                       </a:r>
                     </a:p>
                   </a:txBody>
@@ -5789,7 +5790,7 @@
                           </a:solidFill>
                           <a:latin typeface="Calibri"/>
                         </a:rPr>
-                        <a:t>—</a:t>
+                        <a:t>85.0%</a:t>
                       </a:r>
                     </a:p>
                   </a:txBody>
@@ -5805,13 +5806,13 @@
                     <a:lstStyle/>
                     <a:p>
                       <a:r>
-                        <a:rPr sz="1300" b="0">
+                        <a:rPr sz="1300" b="1">
                           <a:solidFill>
                             <a:srgbClr val="1A1F24"/>
                           </a:solidFill>
                           <a:latin typeface="Calibri"/>
                         </a:rPr>
-                        <a:t>—</a:t>
+                        <a:t>+6.0</a:t>
                       </a:r>
                     </a:p>
                   </a:txBody>
@@ -5822,7 +5823,7 @@
                   </a:tcPr>
                 </a:tc>
               </a:tr>
-              <a:tr h="548640">
+              <a:tr h="522514">
                 <a:tc>
                   <a:txBody>
                     <a:bodyPr/>
@@ -5857,7 +5858,7 @@
                           </a:solidFill>
                           <a:latin typeface="Calibri"/>
                         </a:rPr>
-                        <a:t>—</a:t>
+                        <a:t>85.0%</a:t>
                       </a:r>
                     </a:p>
                   </a:txBody>
@@ -5879,7 +5880,7 @@
                           </a:solidFill>
                           <a:latin typeface="Calibri"/>
                         </a:rPr>
-                        <a:t>—</a:t>
+                        <a:t>96.0%</a:t>
                       </a:r>
                     </a:p>
                   </a:txBody>
@@ -5895,13 +5896,13 @@
                     <a:lstStyle/>
                     <a:p>
                       <a:r>
-                        <a:rPr sz="1300" b="0">
+                        <a:rPr sz="1300" b="1">
                           <a:solidFill>
                             <a:srgbClr val="1A1F24"/>
                           </a:solidFill>
                           <a:latin typeface="Calibri"/>
                         </a:rPr>
-                        <a:t>—</a:t>
+                        <a:t>+11.0</a:t>
                       </a:r>
                     </a:p>
                   </a:txBody>
@@ -5912,7 +5913,7 @@
                   </a:tcPr>
                 </a:tc>
               </a:tr>
-              <a:tr h="548640">
+              <a:tr h="522514">
                 <a:tc>
                   <a:txBody>
                     <a:bodyPr/>
@@ -5947,7 +5948,7 @@
                           </a:solidFill>
                           <a:latin typeface="Calibri"/>
                         </a:rPr>
-                        <a:t>—</a:t>
+                        <a:t>60.0%</a:t>
                       </a:r>
                     </a:p>
                   </a:txBody>
@@ -5969,7 +5970,7 @@
                           </a:solidFill>
                           <a:latin typeface="Calibri"/>
                         </a:rPr>
-                        <a:t>—</a:t>
+                        <a:t>79.0%</a:t>
                       </a:r>
                     </a:p>
                   </a:txBody>
@@ -5985,13 +5986,13 @@
                     <a:lstStyle/>
                     <a:p>
                       <a:r>
-                        <a:rPr sz="1300" b="0">
+                        <a:rPr sz="1300" b="1">
                           <a:solidFill>
                             <a:srgbClr val="1A1F24"/>
                           </a:solidFill>
                           <a:latin typeface="Calibri"/>
                         </a:rPr>
-                        <a:t>—</a:t>
+                        <a:t>+19.0</a:t>
                       </a:r>
                     </a:p>
                   </a:txBody>
@@ -6002,7 +6003,7 @@
                   </a:tcPr>
                 </a:tc>
               </a:tr>
-              <a:tr h="548640">
+              <a:tr h="522514">
                 <a:tc>
                   <a:txBody>
                     <a:bodyPr/>
@@ -6037,7 +6038,7 @@
                           </a:solidFill>
                           <a:latin typeface="Calibri"/>
                         </a:rPr>
-                        <a:t>—</a:t>
+                        <a:t>90.0%</a:t>
                       </a:r>
                     </a:p>
                   </a:txBody>
@@ -6059,7 +6060,7 @@
                           </a:solidFill>
                           <a:latin typeface="Calibri"/>
                         </a:rPr>
-                        <a:t>—</a:t>
+                        <a:t>95.0%</a:t>
                       </a:r>
                     </a:p>
                   </a:txBody>
@@ -6075,13 +6076,13 @@
                     <a:lstStyle/>
                     <a:p>
                       <a:r>
-                        <a:rPr sz="1300" b="0">
+                        <a:rPr sz="1300" b="1">
                           <a:solidFill>
                             <a:srgbClr val="1A1F24"/>
                           </a:solidFill>
                           <a:latin typeface="Calibri"/>
                         </a:rPr>
-                        <a:t>—</a:t>
+                        <a:t>+5.0</a:t>
                       </a:r>
                     </a:p>
                   </a:txBody>
@@ -6092,7 +6093,7 @@
                   </a:tcPr>
                 </a:tc>
               </a:tr>
-              <a:tr h="548640">
+              <a:tr h="522516">
                 <a:tc>
                   <a:txBody>
                     <a:bodyPr/>
@@ -6127,7 +6128,7 @@
                           </a:solidFill>
                           <a:latin typeface="Calibri"/>
                         </a:rPr>
-                        <a:t>—</a:t>
+                        <a:t>89.3%</a:t>
                       </a:r>
                     </a:p>
                   </a:txBody>
@@ -6149,7 +6150,7 @@
                           </a:solidFill>
                           <a:latin typeface="Calibri"/>
                         </a:rPr>
-                        <a:t>—</a:t>
+                        <a:t>96.4%</a:t>
                       </a:r>
                     </a:p>
                   </a:txBody>
@@ -6165,13 +6166,13 @@
                     <a:lstStyle/>
                     <a:p>
                       <a:r>
-                        <a:rPr sz="1300" b="0">
+                        <a:rPr sz="1300" b="1">
                           <a:solidFill>
                             <a:srgbClr val="1A1F24"/>
                           </a:solidFill>
                           <a:latin typeface="Calibri"/>
                         </a:rPr>
-                        <a:t>—</a:t>
+                        <a:t>+7.1</a:t>
                       </a:r>
                     </a:p>
                   </a:txBody>
@@ -6194,8 +6195,53 @@
         </p:nvSpPr>
         <p:spPr>
           <a:xfrm>
-            <a:off x="1097280" y="5577840"/>
-            <a:ext cx="9875520" cy="548640"/>
+            <a:off x="1097280" y="5257800"/>
+            <a:ext cx="9875520" cy="822960"/>
+          </a:xfrm>
+          <a:prstGeom prst="rect">
+            <a:avLst/>
+          </a:prstGeom>
+          <a:noFill/>
+        </p:spPr>
+        <p:txBody>
+          <a:bodyPr wrap="square">
+            <a:spAutoFit/>
+          </a:bodyPr>
+          <a:lstStyle/>
+          <a:p>
+            <a:r>
+              <a:rPr sz="1200" b="0">
+                <a:solidFill>
+                  <a:srgbClr val="C45C26"/>
+                </a:solidFill>
+                <a:latin typeface="Calibri"/>
+              </a:rPr>
+              <a:t>FAILURE 01 — Wrong total blocks approval  ·  e.g. X51006008090 expected 30.50 → predicted 30.48</a:t>
+            </a:r>
+          </a:p>
+          <a:p>
+            <a:r>
+              <a:rPr sz="1200" b="0">
+                <a:solidFill>
+                  <a:srgbClr val="5A656E"/>
+                </a:solidFill>
+                <a:latin typeface="Calibri"/>
+              </a:rPr>
+              <a:t>FAILURE 02 — Plausible company still wrong  ·  e.g. TEO HENG → TED HENG (OCR-style typo)</a:t>
+            </a:r>
+          </a:p>
+        </p:txBody>
+      </p:sp>
+      <p:sp>
+        <p:nvSpPr>
+          <p:cNvPr id="7" name="TextBox 6"/>
+          <p:cNvSpPr txBox="1"/>
+          <p:nvPr/>
+        </p:nvSpPr>
+        <p:spPr>
+          <a:xfrm>
+            <a:off x="502920" y="6446520"/>
+            <a:ext cx="9144000" cy="320040"/>
           </a:xfrm>
           <a:prstGeom prst="rect">
             <a:avLst/>
@@ -6209,27 +6255,27 @@
           <a:lstStyle/>
           <a:p>
             <a:r>
-              <a:rPr sz="1200" b="0">
-                <a:solidFill>
-                  <a:srgbClr val="C45C26"/>
-                </a:solidFill>
-                <a:latin typeface="Calibri"/>
-              </a:rPr>
-              <a:t>After export: copy from results/comparison.csv. M2 owns verification before the deck goes final.</a:t>
-            </a:r>
-          </a:p>
-        </p:txBody>
-      </p:sp>
-      <p:sp>
-        <p:nvSpPr>
-          <p:cNvPr id="7" name="TextBox 6"/>
+              <a:rPr sz="1000" b="0">
+                <a:solidFill>
+                  <a:srgbClr val="5A656E"/>
+                </a:solidFill>
+                <a:latin typeface="Calibri"/>
+              </a:rPr>
+              <a:t>CampusClaim · Theme 3B · notebooks/campusclaim_3b.ipynb</a:t>
+            </a:r>
+          </a:p>
+        </p:txBody>
+      </p:sp>
+      <p:sp>
+        <p:nvSpPr>
+          <p:cNvPr id="8" name="TextBox 7"/>
           <p:cNvSpPr txBox="1"/>
           <p:nvPr/>
         </p:nvSpPr>
         <p:spPr>
           <a:xfrm>
-            <a:off x="502920" y="6446520"/>
-            <a:ext cx="9144000" cy="320040"/>
+            <a:off x="10515600" y="6446520"/>
+            <a:ext cx="1280160" cy="320040"/>
           </a:xfrm>
           <a:prstGeom prst="rect">
             <a:avLst/>
@@ -6242,6 +6288,7 @@
           </a:bodyPr>
           <a:lstStyle/>
           <a:p>
+            <a:pPr algn="r"/>
             <a:r>
               <a:rPr sz="1000" b="0">
                 <a:solidFill>
@@ -6249,42 +6296,7 @@
                 </a:solidFill>
                 <a:latin typeface="Calibri"/>
               </a:rPr>
-              <a:t>CampusClaim · Theme 3B · notebooks/campusclaim_3b.ipynb</a:t>
-            </a:r>
-          </a:p>
-        </p:txBody>
-      </p:sp>
-      <p:sp>
-        <p:nvSpPr>
-          <p:cNvPr id="8" name="TextBox 7"/>
-          <p:cNvSpPr txBox="1"/>
-          <p:nvPr/>
-        </p:nvSpPr>
-        <p:spPr>
-          <a:xfrm>
-            <a:off x="10515600" y="6446520"/>
-            <a:ext cx="1280160" cy="320040"/>
-          </a:xfrm>
-          <a:prstGeom prst="rect">
-            <a:avLst/>
-          </a:prstGeom>
-          <a:noFill/>
-        </p:spPr>
-        <p:txBody>
-          <a:bodyPr wrap="none">
-            <a:spAutoFit/>
-          </a:bodyPr>
-          <a:lstStyle/>
-          <a:p>
-            <a:pPr algn="r"/>
-            <a:r>
-              <a:rPr sz="1000" b="0">
-                <a:solidFill>
-                  <a:srgbClr val="5A656E"/>
-                </a:solidFill>
-                <a:latin typeface="Calibri"/>
-              </a:rPr>
-              <a:t>16 / 28</a:t>
+              <a:t>16 / 29</a:t>
             </a:r>
           </a:p>
         </p:txBody>
@@ -6422,7 +6434,7 @@
                 </a:solidFill>
                 <a:latin typeface="Georgia"/>
               </a:rPr>
-              <a:t>Exports for M2 / M5</a:t>
+              <a:t>Run parameters (settings.json)</a:t>
             </a:r>
           </a:p>
           <a:p>
@@ -6438,7 +6450,7 @@
                 </a:solidFill>
                 <a:latin typeface="Calibri"/>
               </a:rPr>
-              <a:t>results/ folder written by the notebook export cell</a:t>
+              <a:t>Locked hyperparameters for the submitted Colab run</a:t>
             </a:r>
           </a:p>
         </p:txBody>
@@ -6477,7 +6489,7 @@
                 </a:solidFill>
                 <a:latin typeface="Calibri"/>
               </a:rPr>
-              <a:t>baseline_metrics.json · tuned_metrics.json</a:t>
+              <a:t>model: unsloth/gemma-4-E2B-it</a:t>
             </a:r>
           </a:p>
           <a:p>
@@ -6493,7 +6505,7 @@
                 </a:solidFill>
                 <a:latin typeface="Calibri"/>
               </a:rPr>
-              <a:t>comparison.csv · failures.csv</a:t>
+              <a:t>instruction: Extract the company, date, address and total from this receipt. Reply with JSON only.</a:t>
             </a:r>
           </a:p>
           <a:p>
@@ -6509,7 +6521,7 @@
                 </a:solidFill>
                 <a:latin typeface="Calibri"/>
               </a:rPr>
-              <a:t>baseline_predictions.csv · tuned_predictions.csv</a:t>
+              <a:t>eval_keys: 100 · eval_seed: 0</a:t>
             </a:r>
           </a:p>
           <a:p>
@@ -6525,7 +6537,7 @@
                 </a:solidFill>
                 <a:latin typeface="Calibri"/>
               </a:rPr>
-              <a:t>settings.json — model, instruction, eval size/seed, image side, LoRA, steps, LR, batch</a:t>
+              <a:t>image_max_side: 1024</a:t>
             </a:r>
           </a:p>
           <a:p>
@@ -6541,7 +6553,7 @@
                 </a:solidFill>
                 <a:latin typeface="Calibri"/>
               </a:rPr>
-              <a:t>Download the whole results/ folder from the Colab file browser</a:t>
+              <a:t>lora_rank: 16 · train_steps: 120</a:t>
             </a:r>
           </a:p>
           <a:p>
@@ -6557,7 +6569,39 @@
                 </a:solidFill>
                 <a:latin typeface="Calibri"/>
               </a:rPr>
-              <a:t>Also download campusclaim_gemma4_lora.zip immediately after training</a:t>
+              <a:t>learning_rate: 0.0002 · batch_size: 1 · grad_accum: 4</a:t>
+            </a:r>
+          </a:p>
+          <a:p>
+            <a:pPr>
+              <a:spcAft>
+                <a:spcPts val="800"/>
+              </a:spcAft>
+            </a:pPr>
+            <a:r>
+              <a:rPr sz="1600" b="0">
+                <a:solidFill>
+                  <a:srgbClr val="1A1F24"/>
+                </a:solidFill>
+                <a:latin typeface="Calibri"/>
+              </a:rPr>
+              <a:t>max_length: 2048</a:t>
+            </a:r>
+          </a:p>
+          <a:p>
+            <a:pPr>
+              <a:spcAft>
+                <a:spcPts val="800"/>
+              </a:spcAft>
+            </a:pPr>
+            <a:r>
+              <a:rPr sz="1600" b="0">
+                <a:solidFill>
+                  <a:srgbClr val="1A1F24"/>
+                </a:solidFill>
+                <a:latin typeface="Calibri"/>
+              </a:rPr>
+              <a:t>Artifacts: results/ · adapters/campusclaim_gemma4_lora/</a:t>
             </a:r>
           </a:p>
         </p:txBody>
@@ -6626,7 +6670,7 @@
                 </a:solidFill>
                 <a:latin typeface="Calibri"/>
               </a:rPr>
-              <a:t>17 / 28</a:t>
+              <a:t>17 / 29</a:t>
             </a:r>
           </a:p>
         </p:txBody>
@@ -6764,7 +6808,7 @@
                 </a:solidFill>
                 <a:latin typeface="Georgia"/>
               </a:rPr>
-              <a:t>Step 6 — Gradio application</a:t>
+              <a:t>Artifacts now in the repo</a:t>
             </a:r>
           </a:p>
           <a:p>
@@ -6780,277 +6824,124 @@
                 </a:solidFill>
                 <a:latin typeface="Calibri"/>
               </a:rPr>
-              <a:t>Upload → extract (plain vs tuned) → edit → claim draft</a:t>
-            </a:r>
-          </a:p>
-        </p:txBody>
-      </p:sp>
-      <p:sp>
-        <p:nvSpPr>
-          <p:cNvPr id="5" name="Rounded Rectangle 4"/>
-          <p:cNvSpPr/>
-          <p:nvPr/>
-        </p:nvSpPr>
-        <p:spPr>
-          <a:xfrm>
-            <a:off x="502920" y="1417320"/>
-            <a:ext cx="5486400" cy="4389120"/>
-          </a:xfrm>
-          <a:prstGeom prst="roundRect">
-            <a:avLst>
-              <a:gd name="adj" fmla="val 8000"/>
-            </a:avLst>
-          </a:prstGeom>
-          <a:solidFill>
-            <a:srgbClr val="FFFFFF"/>
-          </a:solidFill>
-          <a:ln>
-            <a:solidFill>
-              <a:srgbClr val="E7EEEC"/>
-            </a:solidFill>
-          </a:ln>
-        </p:spPr>
-        <p:style>
-          <a:lnRef idx="1">
-            <a:schemeClr val="accent1"/>
-          </a:lnRef>
-          <a:fillRef idx="3">
-            <a:schemeClr val="accent1"/>
-          </a:fillRef>
-          <a:effectRef idx="2">
-            <a:schemeClr val="accent1"/>
-          </a:effectRef>
-          <a:fontRef idx="minor">
-            <a:schemeClr val="lt1"/>
-          </a:fontRef>
-        </p:style>
-        <p:txBody>
-          <a:bodyPr rtlCol="0" anchor="ctr" wrap="square" lIns="164592" rIns="164592" tIns="128016"/>
-          <a:lstStyle/>
-          <a:p>
-            <a:pPr algn="ctr"/>
-            <a:r>
-              <a:rPr sz="1400" b="1">
-                <a:solidFill>
-                  <a:srgbClr val="1F7A6E"/>
-                </a:solidFill>
-                <a:latin typeface="Calibri"/>
-              </a:rPr>
-              <a:t>In-notebook demo (primary)</a:t>
-            </a:r>
-          </a:p>
-          <a:p>
-            <a:pPr>
-              <a:spcBef>
-                <a:spcPts val="400"/>
-              </a:spcBef>
-            </a:pPr>
-            <a:r>
-              <a:rPr sz="1200" b="0">
-                <a:solidFill>
-                  <a:srgbClr val="1A1F24"/>
-                </a:solidFill>
-                <a:latin typeface="Calibri"/>
-              </a:rPr>
-              <a:t>extract_both: disable_adapter for plain,</a:t>
-            </a:r>
-          </a:p>
-          <a:p>
-            <a:pPr>
-              <a:spcBef>
-                <a:spcPts val="400"/>
-              </a:spcBef>
-            </a:pPr>
-            <a:r>
-              <a:rPr sz="1200" b="0">
-                <a:solidFill>
-                  <a:srgbClr val="1A1F24"/>
-                </a:solidFill>
-                <a:latin typeface="Calibri"/>
-              </a:rPr>
-              <a:t>then tuned with adapters on</a:t>
-            </a:r>
-          </a:p>
-          <a:p>
-            <a:pPr>
-              <a:spcBef>
-                <a:spcPts val="400"/>
-              </a:spcBef>
-            </a:pPr>
-            <a:r>
-              <a:rPr sz="1200" b="0">
-                <a:solidFill>
-                  <a:srgbClr val="1A1F24"/>
-                </a:solidFill>
-                <a:latin typeface="Calibri"/>
-              </a:rPr>
-              <a:t/>
-            </a:r>
-          </a:p>
-          <a:p>
-            <a:pPr>
-              <a:spcBef>
-                <a:spcPts val="400"/>
-              </a:spcBef>
-            </a:pPr>
-            <a:r>
-              <a:rPr sz="1200" b="0">
-                <a:solidFill>
-                  <a:srgbClr val="1A1F24"/>
-                </a:solidFill>
-                <a:latin typeface="Calibri"/>
-              </a:rPr>
-              <a:t>Editable fields: company, date,</a:t>
-            </a:r>
-          </a:p>
-          <a:p>
-            <a:pPr>
-              <a:spcBef>
-                <a:spcPts val="400"/>
-              </a:spcBef>
-            </a:pPr>
-            <a:r>
-              <a:rPr sz="1200" b="0">
-                <a:solidFill>
-                  <a:srgbClr val="1A1F24"/>
-                </a:solidFill>
-                <a:latin typeface="Calibri"/>
-              </a:rPr>
-              <a:t>address, total + purpose</a:t>
-            </a:r>
-          </a:p>
-          <a:p>
-            <a:pPr>
-              <a:spcBef>
-                <a:spcPts val="400"/>
-              </a:spcBef>
-            </a:pPr>
-            <a:r>
-              <a:rPr sz="1200" b="0">
-                <a:solidFill>
-                  <a:srgbClr val="1A1F24"/>
-                </a:solidFill>
-                <a:latin typeface="Calibri"/>
-              </a:rPr>
-              <a:t/>
-            </a:r>
-          </a:p>
-          <a:p>
-            <a:pPr>
-              <a:spcBef>
-                <a:spcPts val="400"/>
-              </a:spcBef>
-            </a:pPr>
-            <a:r>
-              <a:rPr sz="1200" b="0">
-                <a:solidFill>
-                  <a:srgbClr val="1A1F24"/>
-                </a:solidFill>
-                <a:latin typeface="Calibri"/>
-              </a:rPr>
-              <a:t>build_summary marks missing fields</a:t>
-            </a:r>
-          </a:p>
-          <a:p>
-            <a:pPr>
-              <a:spcBef>
-                <a:spcPts val="400"/>
-              </a:spcBef>
-            </a:pPr>
-            <a:r>
-              <a:rPr sz="1200" b="0">
-                <a:solidFill>
-                  <a:srgbClr val="1A1F24"/>
-                </a:solidFill>
-                <a:latin typeface="Calibri"/>
-              </a:rPr>
-              <a:t>and reminds that approval is human</a:t>
-            </a:r>
-          </a:p>
-          <a:p>
-            <a:pPr>
-              <a:spcBef>
-                <a:spcPts val="400"/>
-              </a:spcBef>
-            </a:pPr>
-            <a:r>
-              <a:rPr sz="1200" b="0">
-                <a:solidFill>
-                  <a:srgbClr val="1A1F24"/>
-                </a:solidFill>
-                <a:latin typeface="Calibri"/>
-              </a:rPr>
-              <a:t/>
-            </a:r>
-          </a:p>
-          <a:p>
-            <a:pPr>
-              <a:spcBef>
-                <a:spcPts val="400"/>
-              </a:spcBef>
-            </a:pPr>
-            <a:r>
-              <a:rPr sz="1200" b="0">
-                <a:solidFill>
-                  <a:srgbClr val="1A1F24"/>
-                </a:solidFill>
-                <a:latin typeface="Calibri"/>
-              </a:rPr>
-              <a:t>Standalone app/gradio_app.py is the</a:t>
-            </a:r>
-          </a:p>
-          <a:p>
-            <a:pPr>
-              <a:spcBef>
-                <a:spcPts val="400"/>
-              </a:spcBef>
-            </a:pPr>
-            <a:r>
-              <a:rPr sz="1200" b="0">
-                <a:solidFill>
-                  <a:srgbClr val="1A1F24"/>
-                </a:solidFill>
-                <a:latin typeface="Calibri"/>
-              </a:rPr>
-              <a:t>CPU fallback (dummy or --no-dummy)</a:t>
-            </a:r>
-          </a:p>
-        </p:txBody>
-      </p:sp>
-      <p:pic>
-        <p:nvPicPr>
-          <p:cNvPr id="6" name="Picture 5" descr="01-upload.png"/>
-          <p:cNvPicPr>
-            <a:picLocks noChangeAspect="1"/>
-          </p:cNvPicPr>
-          <p:nvPr/>
-        </p:nvPicPr>
-        <p:blipFill>
-          <a:blip r:embed="rId2"/>
-          <a:stretch>
-            <a:fillRect/>
-          </a:stretch>
-        </p:blipFill>
-        <p:spPr>
-          <a:xfrm>
-            <a:off x="6309360" y="1417320"/>
-            <a:ext cx="714924" cy="960120"/>
-          </a:xfrm>
-          <a:prstGeom prst="rect">
-            <a:avLst/>
-          </a:prstGeom>
-        </p:spPr>
-      </p:pic>
-      <p:sp>
-        <p:nvSpPr>
-          <p:cNvPr id="7" name="TextBox 6"/>
+              <a:t>Committed from the finished Colab download</a:t>
+            </a:r>
+          </a:p>
+        </p:txBody>
+      </p:sp>
+      <p:sp>
+        <p:nvSpPr>
+          <p:cNvPr id="5" name="TextBox 4"/>
           <p:cNvSpPr txBox="1"/>
           <p:nvPr/>
         </p:nvSpPr>
         <p:spPr>
           <a:xfrm>
-            <a:off x="10058400" y="1691640"/>
-            <a:ext cx="1645920" cy="365760"/>
+            <a:off x="502920" y="1371600"/>
+            <a:ext cx="11155680" cy="5029200"/>
+          </a:xfrm>
+          <a:prstGeom prst="rect">
+            <a:avLst/>
+          </a:prstGeom>
+          <a:noFill/>
+        </p:spPr>
+        <p:txBody>
+          <a:bodyPr wrap="square">
+            <a:spAutoFit/>
+          </a:bodyPr>
+          <a:lstStyle/>
+          <a:p>
+            <a:pPr>
+              <a:spcAft>
+                <a:spcPts val="800"/>
+              </a:spcAft>
+            </a:pPr>
+            <a:r>
+              <a:rPr sz="1600" b="0">
+                <a:solidFill>
+                  <a:srgbClr val="1A1F24"/>
+                </a:solidFill>
+                <a:latin typeface="Calibri"/>
+              </a:rPr>
+              <a:t>results/comparison.csv · failures.csv · predictions · metrics · settings.json</a:t>
+            </a:r>
+          </a:p>
+          <a:p>
+            <a:pPr>
+              <a:spcAft>
+                <a:spcPts val="800"/>
+              </a:spcAft>
+            </a:pPr>
+            <a:r>
+              <a:rPr sz="1600" b="0">
+                <a:solidFill>
+                  <a:srgbClr val="1A1F24"/>
+                </a:solidFill>
+                <a:latin typeface="Calibri"/>
+              </a:rPr>
+              <a:t>adapters/campusclaim_gemma4_lora/ (adapter_model.safetensors via Git LFS)</a:t>
+            </a:r>
+          </a:p>
+          <a:p>
+            <a:pPr>
+              <a:spcAft>
+                <a:spcPts val="800"/>
+              </a:spcAft>
+            </a:pPr>
+            <a:r>
+              <a:rPr sz="1600" b="0">
+                <a:solidFill>
+                  <a:srgbClr val="1A1F24"/>
+                </a:solidFill>
+                <a:latin typeface="Calibri"/>
+              </a:rPr>
+              <a:t>docs/results.md filled with the same numbers as the deck</a:t>
+            </a:r>
+          </a:p>
+          <a:p>
+            <a:pPr>
+              <a:spcAft>
+                <a:spcPts val="800"/>
+              </a:spcAft>
+            </a:pPr>
+            <a:r>
+              <a:rPr sz="1600" b="0">
+                <a:solidFill>
+                  <a:srgbClr val="1A1F24"/>
+                </a:solidFill>
+                <a:latin typeface="Calibri"/>
+              </a:rPr>
+              <a:t>Reload: python -m app.gradio_app --no-dummy --base-model-id unsloth/gemma-4-E2B-it \</a:t>
+            </a:r>
+          </a:p>
+          <a:p>
+            <a:pPr lvl="1">
+              <a:spcAft>
+                <a:spcPts val="800"/>
+              </a:spcAft>
+            </a:pPr>
+            <a:r>
+              <a:rPr sz="1400" b="0">
+                <a:solidFill>
+                  <a:srgbClr val="5A656E"/>
+                </a:solidFill>
+                <a:latin typeface="Calibri"/>
+              </a:rPr>
+              <a:t>--adapter-path adapters/campusclaim_gemma4_lora</a:t>
+            </a:r>
+          </a:p>
+        </p:txBody>
+      </p:sp>
+      <p:sp>
+        <p:nvSpPr>
+          <p:cNvPr id="6" name="TextBox 5"/>
+          <p:cNvSpPr txBox="1"/>
+          <p:nvPr/>
+        </p:nvSpPr>
+        <p:spPr>
+          <a:xfrm>
+            <a:off x="502920" y="6446520"/>
+            <a:ext cx="9144000" cy="320040"/>
           </a:xfrm>
           <a:prstGeom prst="rect">
             <a:avLst/>
@@ -7064,51 +6955,27 @@
           <a:lstStyle/>
           <a:p>
             <a:r>
-              <a:rPr sz="1200" b="1">
-                <a:solidFill>
-                  <a:srgbClr val="1F7A6E"/>
-                </a:solidFill>
-                <a:latin typeface="Calibri"/>
-              </a:rPr>
-              <a:t>Upload</a:t>
-            </a:r>
-          </a:p>
-        </p:txBody>
-      </p:sp>
-      <p:pic>
-        <p:nvPicPr>
-          <p:cNvPr id="8" name="Picture 7" descr="02-extraction.png"/>
-          <p:cNvPicPr>
-            <a:picLocks noChangeAspect="1"/>
-          </p:cNvPicPr>
-          <p:nvPr/>
-        </p:nvPicPr>
-        <p:blipFill>
-          <a:blip r:embed="rId3"/>
-          <a:stretch>
-            <a:fillRect/>
-          </a:stretch>
-        </p:blipFill>
-        <p:spPr>
-          <a:xfrm>
-            <a:off x="6309360" y="2514600"/>
-            <a:ext cx="691589" cy="960120"/>
-          </a:xfrm>
-          <a:prstGeom prst="rect">
-            <a:avLst/>
-          </a:prstGeom>
-        </p:spPr>
-      </p:pic>
-      <p:sp>
-        <p:nvSpPr>
-          <p:cNvPr id="9" name="TextBox 8"/>
+              <a:rPr sz="1000" b="0">
+                <a:solidFill>
+                  <a:srgbClr val="5A656E"/>
+                </a:solidFill>
+                <a:latin typeface="Calibri"/>
+              </a:rPr>
+              <a:t>CampusClaim · Theme 3B · notebooks/campusclaim_3b.ipynb</a:t>
+            </a:r>
+          </a:p>
+        </p:txBody>
+      </p:sp>
+      <p:sp>
+        <p:nvSpPr>
+          <p:cNvPr id="7" name="TextBox 6"/>
           <p:cNvSpPr txBox="1"/>
           <p:nvPr/>
         </p:nvSpPr>
         <p:spPr>
           <a:xfrm>
-            <a:off x="10058400" y="2788920"/>
-            <a:ext cx="1645920" cy="365760"/>
+            <a:off x="10515600" y="6446520"/>
+            <a:ext cx="1280160" cy="320040"/>
           </a:xfrm>
           <a:prstGeom prst="rect">
             <a:avLst/>
@@ -7121,156 +6988,7 @@
           </a:bodyPr>
           <a:lstStyle/>
           <a:p>
-            <a:r>
-              <a:rPr sz="1200" b="1">
-                <a:solidFill>
-                  <a:srgbClr val="1F7A6E"/>
-                </a:solidFill>
-                <a:latin typeface="Calibri"/>
-              </a:rPr>
-              <a:t>Extract</a:t>
-            </a:r>
-          </a:p>
-        </p:txBody>
-      </p:sp>
-      <p:pic>
-        <p:nvPicPr>
-          <p:cNvPr id="10" name="Picture 9" descr="03-edited-field.png"/>
-          <p:cNvPicPr>
-            <a:picLocks noChangeAspect="1"/>
-          </p:cNvPicPr>
-          <p:nvPr/>
-        </p:nvPicPr>
-        <p:blipFill>
-          <a:blip r:embed="rId4"/>
-          <a:stretch>
-            <a:fillRect/>
-          </a:stretch>
-        </p:blipFill>
-        <p:spPr>
-          <a:xfrm>
-            <a:off x="6309360" y="3611880"/>
-            <a:ext cx="691589" cy="960120"/>
-          </a:xfrm>
-          <a:prstGeom prst="rect">
-            <a:avLst/>
-          </a:prstGeom>
-        </p:spPr>
-      </p:pic>
-      <p:sp>
-        <p:nvSpPr>
-          <p:cNvPr id="11" name="TextBox 10"/>
-          <p:cNvSpPr txBox="1"/>
-          <p:nvPr/>
-        </p:nvSpPr>
-        <p:spPr>
-          <a:xfrm>
-            <a:off x="10058400" y="3886200"/>
-            <a:ext cx="1645920" cy="365760"/>
-          </a:xfrm>
-          <a:prstGeom prst="rect">
-            <a:avLst/>
-          </a:prstGeom>
-          <a:noFill/>
-        </p:spPr>
-        <p:txBody>
-          <a:bodyPr wrap="none">
-            <a:spAutoFit/>
-          </a:bodyPr>
-          <a:lstStyle/>
-          <a:p>
-            <a:r>
-              <a:rPr sz="1200" b="1">
-                <a:solidFill>
-                  <a:srgbClr val="1F7A6E"/>
-                </a:solidFill>
-                <a:latin typeface="Calibri"/>
-              </a:rPr>
-              <a:t>Edit</a:t>
-            </a:r>
-          </a:p>
-        </p:txBody>
-      </p:sp>
-      <p:pic>
-        <p:nvPicPr>
-          <p:cNvPr id="12" name="Picture 11" descr="04-claim-draft.png"/>
-          <p:cNvPicPr>
-            <a:picLocks noChangeAspect="1"/>
-          </p:cNvPicPr>
-          <p:nvPr/>
-        </p:nvPicPr>
-        <p:blipFill>
-          <a:blip r:embed="rId5"/>
-          <a:stretch>
-            <a:fillRect/>
-          </a:stretch>
-        </p:blipFill>
-        <p:spPr>
-          <a:xfrm>
-            <a:off x="6309360" y="4709159"/>
-            <a:ext cx="691589" cy="960120"/>
-          </a:xfrm>
-          <a:prstGeom prst="rect">
-            <a:avLst/>
-          </a:prstGeom>
-        </p:spPr>
-      </p:pic>
-      <p:sp>
-        <p:nvSpPr>
-          <p:cNvPr id="13" name="TextBox 12"/>
-          <p:cNvSpPr txBox="1"/>
-          <p:nvPr/>
-        </p:nvSpPr>
-        <p:spPr>
-          <a:xfrm>
-            <a:off x="10058400" y="4983479"/>
-            <a:ext cx="1645920" cy="365760"/>
-          </a:xfrm>
-          <a:prstGeom prst="rect">
-            <a:avLst/>
-          </a:prstGeom>
-          <a:noFill/>
-        </p:spPr>
-        <p:txBody>
-          <a:bodyPr wrap="none">
-            <a:spAutoFit/>
-          </a:bodyPr>
-          <a:lstStyle/>
-          <a:p>
-            <a:r>
-              <a:rPr sz="1200" b="1">
-                <a:solidFill>
-                  <a:srgbClr val="1F7A6E"/>
-                </a:solidFill>
-                <a:latin typeface="Calibri"/>
-              </a:rPr>
-              <a:t>Claim</a:t>
-            </a:r>
-          </a:p>
-        </p:txBody>
-      </p:sp>
-      <p:sp>
-        <p:nvSpPr>
-          <p:cNvPr id="14" name="TextBox 13"/>
-          <p:cNvSpPr txBox="1"/>
-          <p:nvPr/>
-        </p:nvSpPr>
-        <p:spPr>
-          <a:xfrm>
-            <a:off x="502920" y="6446520"/>
-            <a:ext cx="9144000" cy="320040"/>
-          </a:xfrm>
-          <a:prstGeom prst="rect">
-            <a:avLst/>
-          </a:prstGeom>
-          <a:noFill/>
-        </p:spPr>
-        <p:txBody>
-          <a:bodyPr wrap="none">
-            <a:spAutoFit/>
-          </a:bodyPr>
-          <a:lstStyle/>
-          <a:p>
+            <a:pPr algn="r"/>
             <a:r>
               <a:rPr sz="1000" b="0">
                 <a:solidFill>
@@ -7278,42 +6996,7 @@
                 </a:solidFill>
                 <a:latin typeface="Calibri"/>
               </a:rPr>
-              <a:t>CampusClaim · Theme 3B · notebooks/campusclaim_3b.ipynb</a:t>
-            </a:r>
-          </a:p>
-        </p:txBody>
-      </p:sp>
-      <p:sp>
-        <p:nvSpPr>
-          <p:cNvPr id="15" name="TextBox 14"/>
-          <p:cNvSpPr txBox="1"/>
-          <p:nvPr/>
-        </p:nvSpPr>
-        <p:spPr>
-          <a:xfrm>
-            <a:off x="10515600" y="6446520"/>
-            <a:ext cx="1280160" cy="320040"/>
-          </a:xfrm>
-          <a:prstGeom prst="rect">
-            <a:avLst/>
-          </a:prstGeom>
-          <a:noFill/>
-        </p:spPr>
-        <p:txBody>
-          <a:bodyPr wrap="none">
-            <a:spAutoFit/>
-          </a:bodyPr>
-          <a:lstStyle/>
-          <a:p>
-            <a:pPr algn="r"/>
-            <a:r>
-              <a:rPr sz="1000" b="0">
-                <a:solidFill>
-                  <a:srgbClr val="5A656E"/>
-                </a:solidFill>
-                <a:latin typeface="Calibri"/>
-              </a:rPr>
-              <a:t>18 / 28</a:t>
+              <a:t>18 / 29</a:t>
             </a:r>
           </a:p>
         </p:txBody>
@@ -7451,7 +7134,7 @@
                 </a:solidFill>
                 <a:latin typeface="Georgia"/>
               </a:rPr>
-              <a:t>5-minute demo script</a:t>
+              <a:t>Step 6 — Gradio application</a:t>
             </a:r>
           </a:p>
           <a:p>
@@ -7467,140 +7150,277 @@
                 </a:solidFill>
                 <a:latin typeface="Calibri"/>
               </a:rPr>
-              <a:t>From docs/demo-script.md / team plan</a:t>
-            </a:r>
-          </a:p>
-        </p:txBody>
-      </p:sp>
-      <p:sp>
-        <p:nvSpPr>
-          <p:cNvPr id="5" name="TextBox 4"/>
+              <a:t>Upload → extract (plain vs tuned) → edit → claim draft</a:t>
+            </a:r>
+          </a:p>
+        </p:txBody>
+      </p:sp>
+      <p:sp>
+        <p:nvSpPr>
+          <p:cNvPr id="5" name="Rounded Rectangle 4"/>
+          <p:cNvSpPr/>
+          <p:nvPr/>
+        </p:nvSpPr>
+        <p:spPr>
+          <a:xfrm>
+            <a:off x="502920" y="1417320"/>
+            <a:ext cx="5486400" cy="4389120"/>
+          </a:xfrm>
+          <a:prstGeom prst="roundRect">
+            <a:avLst>
+              <a:gd name="adj" fmla="val 8000"/>
+            </a:avLst>
+          </a:prstGeom>
+          <a:solidFill>
+            <a:srgbClr val="FFFFFF"/>
+          </a:solidFill>
+          <a:ln>
+            <a:solidFill>
+              <a:srgbClr val="E7EEEC"/>
+            </a:solidFill>
+          </a:ln>
+        </p:spPr>
+        <p:style>
+          <a:lnRef idx="1">
+            <a:schemeClr val="accent1"/>
+          </a:lnRef>
+          <a:fillRef idx="3">
+            <a:schemeClr val="accent1"/>
+          </a:fillRef>
+          <a:effectRef idx="2">
+            <a:schemeClr val="accent1"/>
+          </a:effectRef>
+          <a:fontRef idx="minor">
+            <a:schemeClr val="lt1"/>
+          </a:fontRef>
+        </p:style>
+        <p:txBody>
+          <a:bodyPr rtlCol="0" anchor="ctr" wrap="square" lIns="164592" rIns="164592" tIns="128016"/>
+          <a:lstStyle/>
+          <a:p>
+            <a:pPr algn="ctr"/>
+            <a:r>
+              <a:rPr sz="1400" b="1">
+                <a:solidFill>
+                  <a:srgbClr val="1F7A6E"/>
+                </a:solidFill>
+                <a:latin typeface="Calibri"/>
+              </a:rPr>
+              <a:t>In-notebook demo (primary)</a:t>
+            </a:r>
+          </a:p>
+          <a:p>
+            <a:pPr>
+              <a:spcBef>
+                <a:spcPts val="400"/>
+              </a:spcBef>
+            </a:pPr>
+            <a:r>
+              <a:rPr sz="1200" b="0">
+                <a:solidFill>
+                  <a:srgbClr val="1A1F24"/>
+                </a:solidFill>
+                <a:latin typeface="Calibri"/>
+              </a:rPr>
+              <a:t>extract_both: disable_adapter for plain,</a:t>
+            </a:r>
+          </a:p>
+          <a:p>
+            <a:pPr>
+              <a:spcBef>
+                <a:spcPts val="400"/>
+              </a:spcBef>
+            </a:pPr>
+            <a:r>
+              <a:rPr sz="1200" b="0">
+                <a:solidFill>
+                  <a:srgbClr val="1A1F24"/>
+                </a:solidFill>
+                <a:latin typeface="Calibri"/>
+              </a:rPr>
+              <a:t>then tuned with adapters on</a:t>
+            </a:r>
+          </a:p>
+          <a:p>
+            <a:pPr>
+              <a:spcBef>
+                <a:spcPts val="400"/>
+              </a:spcBef>
+            </a:pPr>
+            <a:r>
+              <a:rPr sz="1200" b="0">
+                <a:solidFill>
+                  <a:srgbClr val="1A1F24"/>
+                </a:solidFill>
+                <a:latin typeface="Calibri"/>
+              </a:rPr>
+              <a:t/>
+            </a:r>
+          </a:p>
+          <a:p>
+            <a:pPr>
+              <a:spcBef>
+                <a:spcPts val="400"/>
+              </a:spcBef>
+            </a:pPr>
+            <a:r>
+              <a:rPr sz="1200" b="0">
+                <a:solidFill>
+                  <a:srgbClr val="1A1F24"/>
+                </a:solidFill>
+                <a:latin typeface="Calibri"/>
+              </a:rPr>
+              <a:t>Editable fields: company, date,</a:t>
+            </a:r>
+          </a:p>
+          <a:p>
+            <a:pPr>
+              <a:spcBef>
+                <a:spcPts val="400"/>
+              </a:spcBef>
+            </a:pPr>
+            <a:r>
+              <a:rPr sz="1200" b="0">
+                <a:solidFill>
+                  <a:srgbClr val="1A1F24"/>
+                </a:solidFill>
+                <a:latin typeface="Calibri"/>
+              </a:rPr>
+              <a:t>address, total + purpose</a:t>
+            </a:r>
+          </a:p>
+          <a:p>
+            <a:pPr>
+              <a:spcBef>
+                <a:spcPts val="400"/>
+              </a:spcBef>
+            </a:pPr>
+            <a:r>
+              <a:rPr sz="1200" b="0">
+                <a:solidFill>
+                  <a:srgbClr val="1A1F24"/>
+                </a:solidFill>
+                <a:latin typeface="Calibri"/>
+              </a:rPr>
+              <a:t/>
+            </a:r>
+          </a:p>
+          <a:p>
+            <a:pPr>
+              <a:spcBef>
+                <a:spcPts val="400"/>
+              </a:spcBef>
+            </a:pPr>
+            <a:r>
+              <a:rPr sz="1200" b="0">
+                <a:solidFill>
+                  <a:srgbClr val="1A1F24"/>
+                </a:solidFill>
+                <a:latin typeface="Calibri"/>
+              </a:rPr>
+              <a:t>build_summary marks missing fields</a:t>
+            </a:r>
+          </a:p>
+          <a:p>
+            <a:pPr>
+              <a:spcBef>
+                <a:spcPts val="400"/>
+              </a:spcBef>
+            </a:pPr>
+            <a:r>
+              <a:rPr sz="1200" b="0">
+                <a:solidFill>
+                  <a:srgbClr val="1A1F24"/>
+                </a:solidFill>
+                <a:latin typeface="Calibri"/>
+              </a:rPr>
+              <a:t>and reminds that approval is human</a:t>
+            </a:r>
+          </a:p>
+          <a:p>
+            <a:pPr>
+              <a:spcBef>
+                <a:spcPts val="400"/>
+              </a:spcBef>
+            </a:pPr>
+            <a:r>
+              <a:rPr sz="1200" b="0">
+                <a:solidFill>
+                  <a:srgbClr val="1A1F24"/>
+                </a:solidFill>
+                <a:latin typeface="Calibri"/>
+              </a:rPr>
+              <a:t/>
+            </a:r>
+          </a:p>
+          <a:p>
+            <a:pPr>
+              <a:spcBef>
+                <a:spcPts val="400"/>
+              </a:spcBef>
+            </a:pPr>
+            <a:r>
+              <a:rPr sz="1200" b="0">
+                <a:solidFill>
+                  <a:srgbClr val="1A1F24"/>
+                </a:solidFill>
+                <a:latin typeface="Calibri"/>
+              </a:rPr>
+              <a:t>Standalone app/gradio_app.py is the</a:t>
+            </a:r>
+          </a:p>
+          <a:p>
+            <a:pPr>
+              <a:spcBef>
+                <a:spcPts val="400"/>
+              </a:spcBef>
+            </a:pPr>
+            <a:r>
+              <a:rPr sz="1200" b="0">
+                <a:solidFill>
+                  <a:srgbClr val="1A1F24"/>
+                </a:solidFill>
+                <a:latin typeface="Calibri"/>
+              </a:rPr>
+              <a:t>CPU fallback (dummy or --no-dummy)</a:t>
+            </a:r>
+          </a:p>
+        </p:txBody>
+      </p:sp>
+      <p:pic>
+        <p:nvPicPr>
+          <p:cNvPr id="6" name="Picture 5" descr="01-upload.png"/>
+          <p:cNvPicPr>
+            <a:picLocks noChangeAspect="1"/>
+          </p:cNvPicPr>
+          <p:nvPr/>
+        </p:nvPicPr>
+        <p:blipFill>
+          <a:blip r:embed="rId2"/>
+          <a:stretch>
+            <a:fillRect/>
+          </a:stretch>
+        </p:blipFill>
+        <p:spPr>
+          <a:xfrm>
+            <a:off x="6309360" y="1417320"/>
+            <a:ext cx="714924" cy="960120"/>
+          </a:xfrm>
+          <a:prstGeom prst="rect">
+            <a:avLst/>
+          </a:prstGeom>
+        </p:spPr>
+      </p:pic>
+      <p:sp>
+        <p:nvSpPr>
+          <p:cNvPr id="7" name="TextBox 6"/>
           <p:cNvSpPr txBox="1"/>
           <p:nvPr/>
         </p:nvSpPr>
         <p:spPr>
           <a:xfrm>
-            <a:off x="502920" y="1371600"/>
-            <a:ext cx="11155680" cy="5029200"/>
-          </a:xfrm>
-          <a:prstGeom prst="rect">
-            <a:avLst/>
-          </a:prstGeom>
-          <a:noFill/>
-        </p:spPr>
-        <p:txBody>
-          <a:bodyPr wrap="square">
-            <a:spAutoFit/>
-          </a:bodyPr>
-          <a:lstStyle/>
-          <a:p>
-            <a:pPr>
-              <a:spcAft>
-                <a:spcPts val="800"/>
-              </a:spcAft>
-            </a:pPr>
-            <a:r>
-              <a:rPr sz="1600" b="0">
-                <a:solidFill>
-                  <a:srgbClr val="1A1F24"/>
-                </a:solidFill>
-                <a:latin typeface="Calibri"/>
-              </a:rPr>
-              <a:t>0:30 — Problem: clubs retype receipts and hunt rules</a:t>
-            </a:r>
-          </a:p>
-          <a:p>
-            <a:pPr>
-              <a:spcAft>
-                <a:spcPts val="800"/>
-              </a:spcAft>
-            </a:pPr>
-            <a:r>
-              <a:rPr sz="1600" b="0">
-                <a:solidFill>
-                  <a:srgbClr val="1A1F24"/>
-                </a:solidFill>
-                <a:latin typeface="Calibri"/>
-              </a:rPr>
-              <a:t>1:30 — Extraction: upload held-out receipt · plain vs fine-tuned side by side · fix one field</a:t>
-            </a:r>
-          </a:p>
-          <a:p>
-            <a:pPr>
-              <a:spcAft>
-                <a:spcPts val="800"/>
-              </a:spcAft>
-            </a:pPr>
-            <a:r>
-              <a:rPr sz="1600" b="0">
-                <a:solidFill>
-                  <a:srgbClr val="1A1F24"/>
-                </a:solidFill>
-                <a:latin typeface="Calibri"/>
-              </a:rPr>
-              <a:t>1:00 — Claim draft from corrected fields · show missing information</a:t>
-            </a:r>
-          </a:p>
-          <a:p>
-            <a:pPr>
-              <a:spcAft>
-                <a:spcPts val="800"/>
-              </a:spcAft>
-            </a:pPr>
-            <a:r>
-              <a:rPr sz="1600" b="0">
-                <a:solidFill>
-                  <a:srgbClr val="1A1F24"/>
-                </a:solidFill>
-                <a:latin typeface="Calibri"/>
-              </a:rPr>
-              <a:t>1:00 — Evidence: metrics table + two failures (include a wrong total)</a:t>
-            </a:r>
-          </a:p>
-          <a:p>
-            <a:pPr>
-              <a:spcAft>
-                <a:spcPts val="800"/>
-              </a:spcAft>
-            </a:pPr>
-            <a:r>
-              <a:rPr sz="1600" b="0">
-                <a:solidFill>
-                  <a:srgbClr val="1A1F24"/>
-                </a:solidFill>
-                <a:latin typeface="Calibri"/>
-              </a:rPr>
-              <a:t>1:00 — Policy (if CP1 green): covered question with citation · uncovered refusal</a:t>
-            </a:r>
-          </a:p>
-          <a:p>
-            <a:pPr>
-              <a:spcAft>
-                <a:spcPts val="800"/>
-              </a:spcAft>
-            </a:pPr>
-            <a:r>
-              <a:rPr sz="1600" b="0">
-                <a:solidFill>
-                  <a:srgbClr val="1A1F24"/>
-                </a:solidFill>
-                <a:latin typeface="Calibri"/>
-              </a:rPr>
-              <a:t>0:30 — Limits: SROIE is Malaysian · local receipts separate · approval stays human</a:t>
-            </a:r>
-          </a:p>
-        </p:txBody>
-      </p:sp>
-      <p:sp>
-        <p:nvSpPr>
-          <p:cNvPr id="6" name="TextBox 5"/>
-          <p:cNvSpPr txBox="1"/>
-          <p:nvPr/>
-        </p:nvSpPr>
-        <p:spPr>
-          <a:xfrm>
-            <a:off x="502920" y="6446520"/>
-            <a:ext cx="9144000" cy="320040"/>
+            <a:off x="10058400" y="1691640"/>
+            <a:ext cx="1645920" cy="365760"/>
           </a:xfrm>
           <a:prstGeom prst="rect">
             <a:avLst/>
@@ -7614,27 +7434,51 @@
           <a:lstStyle/>
           <a:p>
             <a:r>
-              <a:rPr sz="1000" b="0">
-                <a:solidFill>
-                  <a:srgbClr val="5A656E"/>
-                </a:solidFill>
-                <a:latin typeface="Calibri"/>
-              </a:rPr>
-              <a:t>CampusClaim · Theme 3B · notebooks/campusclaim_3b.ipynb</a:t>
-            </a:r>
-          </a:p>
-        </p:txBody>
-      </p:sp>
-      <p:sp>
-        <p:nvSpPr>
-          <p:cNvPr id="7" name="TextBox 6"/>
+              <a:rPr sz="1200" b="1">
+                <a:solidFill>
+                  <a:srgbClr val="1F7A6E"/>
+                </a:solidFill>
+                <a:latin typeface="Calibri"/>
+              </a:rPr>
+              <a:t>Upload</a:t>
+            </a:r>
+          </a:p>
+        </p:txBody>
+      </p:sp>
+      <p:pic>
+        <p:nvPicPr>
+          <p:cNvPr id="8" name="Picture 7" descr="02-extraction.png"/>
+          <p:cNvPicPr>
+            <a:picLocks noChangeAspect="1"/>
+          </p:cNvPicPr>
+          <p:nvPr/>
+        </p:nvPicPr>
+        <p:blipFill>
+          <a:blip r:embed="rId3"/>
+          <a:stretch>
+            <a:fillRect/>
+          </a:stretch>
+        </p:blipFill>
+        <p:spPr>
+          <a:xfrm>
+            <a:off x="6309360" y="2514600"/>
+            <a:ext cx="691589" cy="960120"/>
+          </a:xfrm>
+          <a:prstGeom prst="rect">
+            <a:avLst/>
+          </a:prstGeom>
+        </p:spPr>
+      </p:pic>
+      <p:sp>
+        <p:nvSpPr>
+          <p:cNvPr id="9" name="TextBox 8"/>
           <p:cNvSpPr txBox="1"/>
           <p:nvPr/>
         </p:nvSpPr>
         <p:spPr>
           <a:xfrm>
-            <a:off x="10515600" y="6446520"/>
-            <a:ext cx="1280160" cy="320040"/>
+            <a:off x="10058400" y="2788920"/>
+            <a:ext cx="1645920" cy="365760"/>
           </a:xfrm>
           <a:prstGeom prst="rect">
             <a:avLst/>
@@ -7647,6 +7491,190 @@
           </a:bodyPr>
           <a:lstStyle/>
           <a:p>
+            <a:r>
+              <a:rPr sz="1200" b="1">
+                <a:solidFill>
+                  <a:srgbClr val="1F7A6E"/>
+                </a:solidFill>
+                <a:latin typeface="Calibri"/>
+              </a:rPr>
+              <a:t>Extract</a:t>
+            </a:r>
+          </a:p>
+        </p:txBody>
+      </p:sp>
+      <p:pic>
+        <p:nvPicPr>
+          <p:cNvPr id="10" name="Picture 9" descr="03-edited-field.png"/>
+          <p:cNvPicPr>
+            <a:picLocks noChangeAspect="1"/>
+          </p:cNvPicPr>
+          <p:nvPr/>
+        </p:nvPicPr>
+        <p:blipFill>
+          <a:blip r:embed="rId4"/>
+          <a:stretch>
+            <a:fillRect/>
+          </a:stretch>
+        </p:blipFill>
+        <p:spPr>
+          <a:xfrm>
+            <a:off x="6309360" y="3611880"/>
+            <a:ext cx="691589" cy="960120"/>
+          </a:xfrm>
+          <a:prstGeom prst="rect">
+            <a:avLst/>
+          </a:prstGeom>
+        </p:spPr>
+      </p:pic>
+      <p:sp>
+        <p:nvSpPr>
+          <p:cNvPr id="11" name="TextBox 10"/>
+          <p:cNvSpPr txBox="1"/>
+          <p:nvPr/>
+        </p:nvSpPr>
+        <p:spPr>
+          <a:xfrm>
+            <a:off x="10058400" y="3886200"/>
+            <a:ext cx="1645920" cy="365760"/>
+          </a:xfrm>
+          <a:prstGeom prst="rect">
+            <a:avLst/>
+          </a:prstGeom>
+          <a:noFill/>
+        </p:spPr>
+        <p:txBody>
+          <a:bodyPr wrap="none">
+            <a:spAutoFit/>
+          </a:bodyPr>
+          <a:lstStyle/>
+          <a:p>
+            <a:r>
+              <a:rPr sz="1200" b="1">
+                <a:solidFill>
+                  <a:srgbClr val="1F7A6E"/>
+                </a:solidFill>
+                <a:latin typeface="Calibri"/>
+              </a:rPr>
+              <a:t>Edit</a:t>
+            </a:r>
+          </a:p>
+        </p:txBody>
+      </p:sp>
+      <p:pic>
+        <p:nvPicPr>
+          <p:cNvPr id="12" name="Picture 11" descr="04-claim-draft.png"/>
+          <p:cNvPicPr>
+            <a:picLocks noChangeAspect="1"/>
+          </p:cNvPicPr>
+          <p:nvPr/>
+        </p:nvPicPr>
+        <p:blipFill>
+          <a:blip r:embed="rId5"/>
+          <a:stretch>
+            <a:fillRect/>
+          </a:stretch>
+        </p:blipFill>
+        <p:spPr>
+          <a:xfrm>
+            <a:off x="6309360" y="4709159"/>
+            <a:ext cx="691589" cy="960120"/>
+          </a:xfrm>
+          <a:prstGeom prst="rect">
+            <a:avLst/>
+          </a:prstGeom>
+        </p:spPr>
+      </p:pic>
+      <p:sp>
+        <p:nvSpPr>
+          <p:cNvPr id="13" name="TextBox 12"/>
+          <p:cNvSpPr txBox="1"/>
+          <p:nvPr/>
+        </p:nvSpPr>
+        <p:spPr>
+          <a:xfrm>
+            <a:off x="10058400" y="4983479"/>
+            <a:ext cx="1645920" cy="365760"/>
+          </a:xfrm>
+          <a:prstGeom prst="rect">
+            <a:avLst/>
+          </a:prstGeom>
+          <a:noFill/>
+        </p:spPr>
+        <p:txBody>
+          <a:bodyPr wrap="none">
+            <a:spAutoFit/>
+          </a:bodyPr>
+          <a:lstStyle/>
+          <a:p>
+            <a:r>
+              <a:rPr sz="1200" b="1">
+                <a:solidFill>
+                  <a:srgbClr val="1F7A6E"/>
+                </a:solidFill>
+                <a:latin typeface="Calibri"/>
+              </a:rPr>
+              <a:t>Claim</a:t>
+            </a:r>
+          </a:p>
+        </p:txBody>
+      </p:sp>
+      <p:sp>
+        <p:nvSpPr>
+          <p:cNvPr id="14" name="TextBox 13"/>
+          <p:cNvSpPr txBox="1"/>
+          <p:nvPr/>
+        </p:nvSpPr>
+        <p:spPr>
+          <a:xfrm>
+            <a:off x="502920" y="6446520"/>
+            <a:ext cx="9144000" cy="320040"/>
+          </a:xfrm>
+          <a:prstGeom prst="rect">
+            <a:avLst/>
+          </a:prstGeom>
+          <a:noFill/>
+        </p:spPr>
+        <p:txBody>
+          <a:bodyPr wrap="none">
+            <a:spAutoFit/>
+          </a:bodyPr>
+          <a:lstStyle/>
+          <a:p>
+            <a:r>
+              <a:rPr sz="1000" b="0">
+                <a:solidFill>
+                  <a:srgbClr val="5A656E"/>
+                </a:solidFill>
+                <a:latin typeface="Calibri"/>
+              </a:rPr>
+              <a:t>CampusClaim · Theme 3B · notebooks/campusclaim_3b.ipynb</a:t>
+            </a:r>
+          </a:p>
+        </p:txBody>
+      </p:sp>
+      <p:sp>
+        <p:nvSpPr>
+          <p:cNvPr id="15" name="TextBox 14"/>
+          <p:cNvSpPr txBox="1"/>
+          <p:nvPr/>
+        </p:nvSpPr>
+        <p:spPr>
+          <a:xfrm>
+            <a:off x="10515600" y="6446520"/>
+            <a:ext cx="1280160" cy="320040"/>
+          </a:xfrm>
+          <a:prstGeom prst="rect">
+            <a:avLst/>
+          </a:prstGeom>
+          <a:noFill/>
+        </p:spPr>
+        <p:txBody>
+          <a:bodyPr wrap="none">
+            <a:spAutoFit/>
+          </a:bodyPr>
+          <a:lstStyle/>
+          <a:p>
             <a:pPr algn="r"/>
             <a:r>
               <a:rPr sz="1000" b="0">
@@ -7655,7 +7683,7 @@
                 </a:solidFill>
                 <a:latin typeface="Calibri"/>
               </a:rPr>
-              <a:t>19 / 28</a:t>
+              <a:t>19 / 29</a:t>
             </a:r>
           </a:p>
         </p:txBody>
@@ -8013,7 +8041,7 @@
                 </a:solidFill>
                 <a:latin typeface="Calibri"/>
               </a:rPr>
-              <a:t>2 / 28</a:t>
+              <a:t>2 / 29</a:t>
             </a:r>
           </a:p>
         </p:txBody>
@@ -8151,7 +8179,7 @@
                 </a:solidFill>
                 <a:latin typeface="Georgia"/>
               </a:rPr>
-              <a:t>Step 7 — Save adapters before disconnect</a:t>
+              <a:t>5-minute demo script</a:t>
             </a:r>
           </a:p>
           <a:p>
@@ -8167,7 +8195,7 @@
                 </a:solidFill>
                 <a:latin typeface="Calibri"/>
               </a:rPr>
-              <a:t>Free Colab can die without warning</a:t>
+              <a:t>From docs/demo-script.md / team plan</a:t>
             </a:r>
           </a:p>
         </p:txBody>
@@ -8206,7 +8234,7 @@
                 </a:solidFill>
                 <a:latin typeface="Calibri"/>
               </a:rPr>
-              <a:t>model.save_pretrained("campusclaim_gemma4_lora")</a:t>
+              <a:t>0:30 — Problem: clubs retype receipts and hunt rules</a:t>
             </a:r>
           </a:p>
           <a:p>
@@ -8222,7 +8250,7 @@
                 </a:solidFill>
                 <a:latin typeface="Calibri"/>
               </a:rPr>
-              <a:t>processor.save_pretrained(...)</a:t>
+              <a:t>1:30 — Extraction: upload held-out receipt · plain vs fine-tuned side by side · fix one field</a:t>
             </a:r>
           </a:p>
           <a:p>
@@ -8238,7 +8266,7 @@
                 </a:solidFill>
                 <a:latin typeface="Calibri"/>
               </a:rPr>
-              <a:t>zip the folder → campusclaim_gemma4_lora.zip</a:t>
+              <a:t>1:00 — Claim draft from corrected fields · show missing information</a:t>
             </a:r>
           </a:p>
           <a:p>
@@ -8254,7 +8282,7 @@
                 </a:solidFill>
                 <a:latin typeface="Calibri"/>
               </a:rPr>
-              <a:t>Copy to Google Drive immediately after training</a:t>
+              <a:t>1:00 — Evidence: metrics table + two failures (include a wrong total)</a:t>
             </a:r>
           </a:p>
           <a:p>
@@ -8270,7 +8298,7 @@
                 </a:solidFill>
                 <a:latin typeface="Calibri"/>
               </a:rPr>
-              <a:t>On reconnect: reload base model → load adapters → re-run eval/app only</a:t>
+              <a:t>1:00 — Policy (if CP1 green): covered question with citation · uncovered refusal</a:t>
             </a:r>
           </a:p>
           <a:p>
@@ -8286,7 +8314,7 @@
                 </a:solidFill>
                 <a:latin typeface="Calibri"/>
               </a:rPr>
-              <a:t>Optional: push_to_hub with a Hugging Face token</a:t>
+              <a:t>0:30 — Limits: SROIE is Malaysian · local receipts separate · approval stays human</a:t>
             </a:r>
           </a:p>
         </p:txBody>
@@ -8355,7 +8383,7 @@
                 </a:solidFill>
                 <a:latin typeface="Calibri"/>
               </a:rPr>
-              <a:t>20 / 28</a:t>
+              <a:t>20 / 29</a:t>
             </a:r>
           </a:p>
         </p:txBody>
@@ -8493,7 +8521,7 @@
                 </a:solidFill>
                 <a:latin typeface="Georgia"/>
               </a:rPr>
-              <a:t>Optional bonus — policy RAG</a:t>
+              <a:t>Step 7 — Save adapters before disconnect</a:t>
             </a:r>
           </a:p>
           <a:p>
@@ -8509,7 +8537,7 @@
                 </a:solidFill>
                 <a:latin typeface="Calibri"/>
               </a:rPr>
-              <a:t>Only after Checkpoint 1 (baseline + fine-tune + app green)</a:t>
+              <a:t>Free Colab can die without warning</a:t>
             </a:r>
           </a:p>
         </p:txBody>
@@ -8548,7 +8576,7 @@
                 </a:solidFill>
                 <a:latin typeface="Calibri"/>
               </a:rPr>
-              <a:t>Separate notebook — do not mix RAG into the GPU extraction notebook</a:t>
+              <a:t>model.save_pretrained("campusclaim_gemma4_lora")</a:t>
             </a:r>
           </a:p>
           <a:p>
@@ -8564,7 +8592,7 @@
                 </a:solidFill>
                 <a:latin typeface="Calibri"/>
               </a:rPr>
-              <a:t>Proxy docs shortlisted: SNU student reimbursement policy · IIIT Una SAC policy</a:t>
+              <a:t>processor.save_pretrained(...)</a:t>
             </a:r>
           </a:p>
           <a:p>
@@ -8580,7 +8608,7 @@
                 </a:solidFill>
                 <a:latin typeface="Calibri"/>
               </a:rPr>
-              <a:t>15-question test: 10 covered · 5 must refuse</a:t>
+              <a:t>zip the folder → campusclaim_gemma4_lora.zip</a:t>
             </a:r>
           </a:p>
           <a:p>
@@ -8596,7 +8624,7 @@
                 </a:solidFill>
                 <a:latin typeface="Calibri"/>
               </a:rPr>
-              <a:t>Every answer cites document + page; never invent policy</a:t>
+              <a:t>Copy to Google Drive immediately after training</a:t>
             </a:r>
           </a:p>
           <a:p>
@@ -8612,7 +8640,7 @@
                 </a:solidFill>
                 <a:latin typeface="Calibri"/>
               </a:rPr>
-              <a:t>If RAG is not green by CP2 — hide the tab; do not demo a broken feature</a:t>
+              <a:t>On reconnect: reload base model → load adapters → re-run eval/app only</a:t>
             </a:r>
           </a:p>
           <a:p>
@@ -8628,7 +8656,7 @@
                 </a:solidFill>
                 <a:latin typeface="Calibri"/>
               </a:rPr>
-              <a:t>Deck must say policy docs are institutional proxies unless college PDFs arrive</a:t>
+              <a:t>Optional: push_to_hub with a Hugging Face token</a:t>
             </a:r>
           </a:p>
         </p:txBody>
@@ -8697,7 +8725,7 @@
                 </a:solidFill>
                 <a:latin typeface="Calibri"/>
               </a:rPr>
-              <a:t>21 / 28</a:t>
+              <a:t>21 / 29</a:t>
             </a:r>
           </a:p>
         </p:txBody>
@@ -8835,7 +8863,7 @@
                 </a:solidFill>
                 <a:latin typeface="Georgia"/>
               </a:rPr>
-              <a:t>Honest reporting notes</a:t>
+              <a:t>Optional bonus — policy RAG</a:t>
             </a:r>
           </a:p>
           <a:p>
@@ -8851,7 +8879,7 @@
                 </a:solidFill>
                 <a:latin typeface="Calibri"/>
               </a:rPr>
-              <a:t>From the notebook’s closing markdown — judges reward clarity over hype</a:t>
+              <a:t>Only after Checkpoint 1 (baseline + fine-tune + app green)</a:t>
             </a:r>
           </a:p>
         </p:txBody>
@@ -8890,7 +8918,7 @@
                 </a:solidFill>
                 <a:latin typeface="Calibri"/>
               </a:rPr>
-              <a:t>SROIE is Malaysian (RM, dd/mm/yyyy) — campus receipts are a domain shift</a:t>
+              <a:t>Separate notebook — do not mix RAG into the GPU extraction notebook</a:t>
             </a:r>
           </a:p>
           <a:p>
@@ -8906,7 +8934,7 @@
                 </a:solidFill>
                 <a:latin typeface="Calibri"/>
               </a:rPr>
-              <a:t>Report valid JSON separately from field accuracy</a:t>
+              <a:t>Proxy docs shortlisted: SNU student reimbursement policy · IIIT Una SAC policy</a:t>
             </a:r>
           </a:p>
           <a:p>
@@ -8922,7 +8950,7 @@
                 </a:solidFill>
                 <a:latin typeface="Calibri"/>
               </a:rPr>
-              <a:t>Exact address match is strict — always pair with token-F1</a:t>
+              <a:t>15-question test: 10 covered · 5 must refuse</a:t>
             </a:r>
           </a:p>
           <a:p>
@@ -8938,7 +8966,7 @@
                 </a:solidFill>
                 <a:latin typeface="Calibri"/>
               </a:rPr>
-              <a:t>State eval subset size and seed (100 · seed 0)</a:t>
+              <a:t>Every answer cites document + page; never invent policy</a:t>
             </a:r>
           </a:p>
           <a:p>
@@ -8954,7 +8982,7 @@
                 </a:solidFill>
                 <a:latin typeface="Calibri"/>
               </a:rPr>
-              <a:t>Never compare a 100-receipt baseline with a 361-receipt fine-tuned run</a:t>
+              <a:t>If RAG is not green by CP2 — hide the tab; do not demo a broken feature</a:t>
             </a:r>
           </a:p>
           <a:p>
@@ -8970,7 +8998,7 @@
                 </a:solidFill>
                 <a:latin typeface="Calibri"/>
               </a:rPr>
-              <a:t>If fine-tuning loses on a field — show it; the problem statement asks for that analysis</a:t>
+              <a:t>Deck must say policy docs are institutional proxies unless college PDFs arrive</a:t>
             </a:r>
           </a:p>
         </p:txBody>
@@ -9039,7 +9067,7 @@
                 </a:solidFill>
                 <a:latin typeface="Calibri"/>
               </a:rPr>
-              <a:t>22 / 28</a:t>
+              <a:t>22 / 29</a:t>
             </a:r>
           </a:p>
         </p:txBody>
@@ -9177,7 +9205,7 @@
                 </a:solidFill>
                 <a:latin typeface="Georgia"/>
               </a:rPr>
-              <a:t>Cut lines &amp; fallbacks</a:t>
+              <a:t>Honest reporting notes</a:t>
             </a:r>
           </a:p>
           <a:p>
@@ -9193,7 +9221,7 @@
                 </a:solidFill>
                 <a:latin typeface="Calibri"/>
               </a:rPr>
-              <a:t>From docs/team-plan.md — decide early, record what you did</a:t>
+              <a:t>From the notebook’s closing markdown — judges reward clarity over hype</a:t>
             </a:r>
           </a:p>
         </p:txBody>
@@ -9232,7 +9260,7 @@
                 </a:solidFill>
                 <a:latin typeface="Calibri"/>
               </a:rPr>
-              <a:t>CUDA OOM → keep 4-bit · freeze vision layers · lower image side / max_length</a:t>
+              <a:t>SROIE is Malaysian (RM, dd/mm/yyyy) — campus receipts are a domain shift</a:t>
             </a:r>
           </a:p>
           <a:p>
@@ -9248,7 +9276,7 @@
                 </a:solidFill>
                 <a:latin typeface="Calibri"/>
               </a:rPr>
-              <a:t>Training &gt; 30 min → stop, save, evaluate actual step count</a:t>
+              <a:t>Report valid JSON separately from field accuracy</a:t>
             </a:r>
           </a:p>
           <a:p>
@@ -9264,7 +9292,7 @@
                 </a:solidFill>
                 <a:latin typeface="Calibri"/>
               </a:rPr>
-              <a:t>Colab disconnect → reload base + adapters from Drive · eval/app only</a:t>
+              <a:t>Exact address match is strict — always pair with token-F1</a:t>
             </a:r>
           </a:p>
           <a:p>
@@ -9280,7 +9308,7 @@
                 </a:solidFill>
                 <a:latin typeface="Calibri"/>
               </a:rPr>
-              <a:t>GPU quota gone → switch Google account (notebook is account-agnostic)</a:t>
+              <a:t>State eval subset size and seed (100 · seed 0)</a:t>
             </a:r>
           </a:p>
           <a:p>
@@ -9296,7 +9324,7 @@
                 </a:solidFill>
                 <a:latin typeface="Calibri"/>
               </a:rPr>
-              <a:t>Fine-tuned worse → report honestly · use prompted baseline as comparison</a:t>
+              <a:t>Never compare a 100-receipt baseline with a 361-receipt fine-tuned run</a:t>
             </a:r>
           </a:p>
           <a:p>
@@ -9312,7 +9340,7 @@
                 </a:solidFill>
                 <a:latin typeface="Calibri"/>
               </a:rPr>
-              <a:t>RAG scanned PDFs → replace or drop bonus</a:t>
+              <a:t>If fine-tuning loses on a field — show it; the problem statement asks for that analysis</a:t>
             </a:r>
           </a:p>
         </p:txBody>
@@ -9381,7 +9409,7 @@
                 </a:solidFill>
                 <a:latin typeface="Calibri"/>
               </a:rPr>
-              <a:t>23 / 28</a:t>
+              <a:t>23 / 29</a:t>
             </a:r>
           </a:p>
         </p:txBody>
@@ -9519,7 +9547,7 @@
                 </a:solidFill>
                 <a:latin typeface="Georgia"/>
               </a:rPr>
-              <a:t>Repo companion pieces</a:t>
+              <a:t>Cut lines &amp; fallbacks</a:t>
             </a:r>
           </a:p>
           <a:p>
@@ -9535,7 +9563,7 @@
                 </a:solidFill>
                 <a:latin typeface="Calibri"/>
               </a:rPr>
-              <a:t>What lives outside the notebook but supports the same story</a:t>
+              <a:t>From docs/team-plan.md — decide early, record what you did</a:t>
             </a:r>
           </a:p>
         </p:txBody>
@@ -9574,7 +9602,7 @@
                 </a:solidFill>
                 <a:latin typeface="Calibri"/>
               </a:rPr>
-              <a:t>app/inference.py — mirrors generate_from_image for the standalone Gradio app</a:t>
+              <a:t>CUDA OOM → keep 4-bit · freeze vision layers · lower image side / max_length</a:t>
             </a:r>
           </a:p>
           <a:p>
@@ -9590,7 +9618,7 @@
                 </a:solidFill>
                 <a:latin typeface="Calibri"/>
               </a:rPr>
-              <a:t>app/gradio_app.py — dummy by default · --no-dummy with adapter path</a:t>
+              <a:t>Training &gt; 30 min → stop, save, evaluate actual step count</a:t>
             </a:r>
           </a:p>
           <a:p>
@@ -9606,7 +9634,7 @@
                 </a:solidFill>
                 <a:latin typeface="Calibri"/>
               </a:rPr>
-              <a:t>scripts/score.py · validate_notebook.py · demo_pipeline.py · freeze_eval_sample.py</a:t>
+              <a:t>Colab disconnect → reload base + adapters from Drive · eval/app only</a:t>
             </a:r>
           </a:p>
           <a:p>
@@ -9622,7 +9650,7 @@
                 </a:solidFill>
                 <a:latin typeface="Calibri"/>
               </a:rPr>
-              <a:t>tests/ — 40 standard-library tests · bash scripts/check.sh = CI</a:t>
+              <a:t>GPU quota gone → switch Google account (notebook is account-agnostic)</a:t>
             </a:r>
           </a:p>
           <a:p>
@@ -9638,7 +9666,7 @@
                 </a:solidFill>
                 <a:latin typeface="Calibri"/>
               </a:rPr>
-              <a:t>dev = integration branch · main = submitted baseline</a:t>
+              <a:t>Fine-tuned worse → report honestly · use prompted baseline as comparison</a:t>
             </a:r>
           </a:p>
           <a:p>
@@ -9654,7 +9682,7 @@
                 </a:solidFill>
                 <a:latin typeface="Calibri"/>
               </a:rPr>
-              <a:t>GPU work stays in Colab; local checks stay CPU-only</a:t>
+              <a:t>RAG scanned PDFs → replace or drop bonus</a:t>
             </a:r>
           </a:p>
         </p:txBody>
@@ -9723,7 +9751,7 @@
                 </a:solidFill>
                 <a:latin typeface="Calibri"/>
               </a:rPr>
-              <a:t>24 / 28</a:t>
+              <a:t>24 / 29</a:t>
             </a:r>
           </a:p>
         </p:txBody>
@@ -9861,7 +9889,7 @@
                 </a:solidFill>
                 <a:latin typeface="Georgia"/>
               </a:rPr>
-              <a:t>Team ownership (Hack Day 3B)</a:t>
+              <a:t>Repo companion pieces</a:t>
             </a:r>
           </a:p>
           <a:p>
@@ -9877,534 +9905,133 @@
                 </a:solidFill>
                 <a:latin typeface="Calibri"/>
               </a:rPr>
-              <a:t>Only M1 edits the shared notebook; others use SCRATCH</a:t>
-            </a:r>
-          </a:p>
-        </p:txBody>
-      </p:sp>
-      <p:sp>
-        <p:nvSpPr>
-          <p:cNvPr id="5" name="Rounded Rectangle 4"/>
-          <p:cNvSpPr/>
-          <p:nvPr/>
-        </p:nvSpPr>
-        <p:spPr>
-          <a:xfrm>
-            <a:off x="502920" y="1554480"/>
-            <a:ext cx="2148840" cy="3840480"/>
-          </a:xfrm>
-          <a:prstGeom prst="roundRect">
-            <a:avLst>
-              <a:gd name="adj" fmla="val 8000"/>
-            </a:avLst>
-          </a:prstGeom>
-          <a:solidFill>
-            <a:srgbClr val="FFFFFF"/>
-          </a:solidFill>
-          <a:ln>
-            <a:solidFill>
-              <a:srgbClr val="E7EEEC"/>
-            </a:solidFill>
-          </a:ln>
-        </p:spPr>
-        <p:style>
-          <a:lnRef idx="1">
-            <a:schemeClr val="accent1"/>
-          </a:lnRef>
-          <a:fillRef idx="3">
-            <a:schemeClr val="accent1"/>
-          </a:fillRef>
-          <a:effectRef idx="2">
-            <a:schemeClr val="accent1"/>
-          </a:effectRef>
-          <a:fontRef idx="minor">
-            <a:schemeClr val="lt1"/>
-          </a:fontRef>
-        </p:style>
-        <p:txBody>
-          <a:bodyPr rtlCol="0" anchor="ctr" wrap="square" lIns="164592" rIns="164592" tIns="128016"/>
-          <a:lstStyle/>
-          <a:p>
-            <a:pPr algn="ctr"/>
-            <a:r>
-              <a:rPr sz="1400" b="1">
-                <a:solidFill>
-                  <a:srgbClr val="1F7A6E"/>
-                </a:solidFill>
-                <a:latin typeface="Calibri"/>
-              </a:rPr>
-              <a:t>M1</a:t>
-            </a:r>
-          </a:p>
-          <a:p>
-            <a:pPr>
-              <a:spcBef>
-                <a:spcPts val="400"/>
-              </a:spcBef>
-            </a:pPr>
-            <a:r>
-              <a:rPr sz="1200" b="0">
-                <a:solidFill>
-                  <a:srgbClr val="1A1F24"/>
-                </a:solidFill>
-                <a:latin typeface="Calibri"/>
-              </a:rPr>
-              <a:t>Notebook + fine-tune</a:t>
-            </a:r>
-          </a:p>
-          <a:p>
-            <a:pPr>
-              <a:spcBef>
-                <a:spcPts val="400"/>
-              </a:spcBef>
-            </a:pPr>
-            <a:r>
-              <a:rPr sz="1200" b="0">
-                <a:solidFill>
-                  <a:srgbClr val="1A1F24"/>
-                </a:solidFill>
-                <a:latin typeface="Calibri"/>
-              </a:rPr>
-              <a:t/>
-            </a:r>
-          </a:p>
-          <a:p>
-            <a:pPr>
-              <a:spcBef>
-                <a:spcPts val="400"/>
-              </a:spcBef>
-            </a:pPr>
-            <a:r>
-              <a:rPr sz="1200" b="0">
-                <a:solidFill>
-                  <a:srgbClr val="1A1F24"/>
-                </a:solidFill>
-                <a:latin typeface="Calibri"/>
-              </a:rPr>
-              <a:t>Colab run, adapters, smoke gate</a:t>
-            </a:r>
-          </a:p>
-        </p:txBody>
-      </p:sp>
-      <p:sp>
-        <p:nvSpPr>
-          <p:cNvPr id="6" name="Rounded Rectangle 5"/>
-          <p:cNvSpPr/>
-          <p:nvPr/>
-        </p:nvSpPr>
-        <p:spPr>
-          <a:xfrm>
-            <a:off x="2788920" y="1554480"/>
-            <a:ext cx="2148840" cy="3840480"/>
-          </a:xfrm>
-          <a:prstGeom prst="roundRect">
-            <a:avLst>
-              <a:gd name="adj" fmla="val 8000"/>
-            </a:avLst>
-          </a:prstGeom>
-          <a:solidFill>
-            <a:srgbClr val="FFFFFF"/>
-          </a:solidFill>
-          <a:ln>
-            <a:solidFill>
-              <a:srgbClr val="E7EEEC"/>
-            </a:solidFill>
-          </a:ln>
-        </p:spPr>
-        <p:style>
-          <a:lnRef idx="1">
-            <a:schemeClr val="accent1"/>
-          </a:lnRef>
-          <a:fillRef idx="3">
-            <a:schemeClr val="accent1"/>
-          </a:fillRef>
-          <a:effectRef idx="2">
-            <a:schemeClr val="accent1"/>
-          </a:effectRef>
-          <a:fontRef idx="minor">
-            <a:schemeClr val="lt1"/>
-          </a:fontRef>
-        </p:style>
-        <p:txBody>
-          <a:bodyPr rtlCol="0" anchor="ctr" wrap="square" lIns="164592" rIns="164592" tIns="128016"/>
-          <a:lstStyle/>
-          <a:p>
-            <a:pPr algn="ctr"/>
-            <a:r>
-              <a:rPr sz="1400" b="1">
-                <a:solidFill>
-                  <a:srgbClr val="1F7A6E"/>
-                </a:solidFill>
-                <a:latin typeface="Calibri"/>
-              </a:rPr>
-              <a:t>M2</a:t>
-            </a:r>
-          </a:p>
-          <a:p>
-            <a:pPr>
-              <a:spcBef>
-                <a:spcPts val="400"/>
-              </a:spcBef>
-            </a:pPr>
-            <a:r>
-              <a:rPr sz="1200" b="0">
-                <a:solidFill>
-                  <a:srgbClr val="1A1F24"/>
-                </a:solidFill>
-                <a:latin typeface="Calibri"/>
-              </a:rPr>
-              <a:t>Eval + metrics</a:t>
-            </a:r>
-          </a:p>
-          <a:p>
-            <a:pPr>
-              <a:spcBef>
-                <a:spcPts val="400"/>
-              </a:spcBef>
-            </a:pPr>
-            <a:r>
-              <a:rPr sz="1200" b="0">
-                <a:solidFill>
-                  <a:srgbClr val="1A1F24"/>
-                </a:solidFill>
-                <a:latin typeface="Calibri"/>
-              </a:rPr>
-              <a:t/>
-            </a:r>
-          </a:p>
-          <a:p>
-            <a:pPr>
-              <a:spcBef>
-                <a:spcPts val="400"/>
-              </a:spcBef>
-            </a:pPr>
-            <a:r>
-              <a:rPr sz="1200" b="0">
-                <a:solidFill>
-                  <a:srgbClr val="1A1F24"/>
-                </a:solidFill>
-                <a:latin typeface="Calibri"/>
-              </a:rPr>
-              <a:t>Frozen keys, comparison, failures</a:t>
-            </a:r>
-          </a:p>
-        </p:txBody>
-      </p:sp>
-      <p:sp>
-        <p:nvSpPr>
-          <p:cNvPr id="7" name="Rounded Rectangle 6"/>
-          <p:cNvSpPr/>
-          <p:nvPr/>
-        </p:nvSpPr>
-        <p:spPr>
-          <a:xfrm>
-            <a:off x="5074920" y="1554480"/>
-            <a:ext cx="2148840" cy="3840480"/>
-          </a:xfrm>
-          <a:prstGeom prst="roundRect">
-            <a:avLst>
-              <a:gd name="adj" fmla="val 8000"/>
-            </a:avLst>
-          </a:prstGeom>
-          <a:solidFill>
-            <a:srgbClr val="FFFFFF"/>
-          </a:solidFill>
-          <a:ln>
-            <a:solidFill>
-              <a:srgbClr val="E7EEEC"/>
-            </a:solidFill>
-          </a:ln>
-        </p:spPr>
-        <p:style>
-          <a:lnRef idx="1">
-            <a:schemeClr val="accent1"/>
-          </a:lnRef>
-          <a:fillRef idx="3">
-            <a:schemeClr val="accent1"/>
-          </a:fillRef>
-          <a:effectRef idx="2">
-            <a:schemeClr val="accent1"/>
-          </a:effectRef>
-          <a:fontRef idx="minor">
-            <a:schemeClr val="lt1"/>
-          </a:fontRef>
-        </p:style>
-        <p:txBody>
-          <a:bodyPr rtlCol="0" anchor="ctr" wrap="square" lIns="164592" rIns="164592" tIns="128016"/>
-          <a:lstStyle/>
-          <a:p>
-            <a:pPr algn="ctr"/>
-            <a:r>
-              <a:rPr sz="1400" b="1">
-                <a:solidFill>
-                  <a:srgbClr val="1F7A6E"/>
-                </a:solidFill>
-                <a:latin typeface="Calibri"/>
-              </a:rPr>
-              <a:t>M3</a:t>
-            </a:r>
-          </a:p>
-          <a:p>
-            <a:pPr>
-              <a:spcBef>
-                <a:spcPts val="400"/>
-              </a:spcBef>
-            </a:pPr>
-            <a:r>
-              <a:rPr sz="1200" b="0">
-                <a:solidFill>
-                  <a:srgbClr val="1A1F24"/>
-                </a:solidFill>
-                <a:latin typeface="Calibri"/>
-              </a:rPr>
-              <a:t>App + demo</a:t>
-            </a:r>
-          </a:p>
-          <a:p>
-            <a:pPr>
-              <a:spcBef>
-                <a:spcPts val="400"/>
-              </a:spcBef>
-            </a:pPr>
-            <a:r>
-              <a:rPr sz="1200" b="0">
-                <a:solidFill>
-                  <a:srgbClr val="1A1F24"/>
-                </a:solidFill>
-                <a:latin typeface="Calibri"/>
-              </a:rPr>
-              <a:t/>
-            </a:r>
-          </a:p>
-          <a:p>
-            <a:pPr>
-              <a:spcBef>
-                <a:spcPts val="400"/>
-              </a:spcBef>
-            </a:pPr>
-            <a:r>
-              <a:rPr sz="1200" b="0">
-                <a:solidFill>
-                  <a:srgbClr val="1A1F24"/>
-                </a:solidFill>
-                <a:latin typeface="Calibri"/>
-              </a:rPr>
-              <a:t>Gradio, screenshots, backup clip</a:t>
-            </a:r>
-          </a:p>
-        </p:txBody>
-      </p:sp>
-      <p:sp>
-        <p:nvSpPr>
-          <p:cNvPr id="8" name="Rounded Rectangle 7"/>
-          <p:cNvSpPr/>
-          <p:nvPr/>
-        </p:nvSpPr>
-        <p:spPr>
-          <a:xfrm>
-            <a:off x="7360920" y="1554480"/>
-            <a:ext cx="2148840" cy="3840480"/>
-          </a:xfrm>
-          <a:prstGeom prst="roundRect">
-            <a:avLst>
-              <a:gd name="adj" fmla="val 8000"/>
-            </a:avLst>
-          </a:prstGeom>
-          <a:solidFill>
-            <a:srgbClr val="FFFFFF"/>
-          </a:solidFill>
-          <a:ln>
-            <a:solidFill>
-              <a:srgbClr val="E7EEEC"/>
-            </a:solidFill>
-          </a:ln>
-        </p:spPr>
-        <p:style>
-          <a:lnRef idx="1">
-            <a:schemeClr val="accent1"/>
-          </a:lnRef>
-          <a:fillRef idx="3">
-            <a:schemeClr val="accent1"/>
-          </a:fillRef>
-          <a:effectRef idx="2">
-            <a:schemeClr val="accent1"/>
-          </a:effectRef>
-          <a:fontRef idx="minor">
-            <a:schemeClr val="lt1"/>
-          </a:fontRef>
-        </p:style>
-        <p:txBody>
-          <a:bodyPr rtlCol="0" anchor="ctr" wrap="square" lIns="164592" rIns="164592" tIns="128016"/>
-          <a:lstStyle/>
-          <a:p>
-            <a:pPr algn="ctr"/>
-            <a:r>
-              <a:rPr sz="1400" b="1">
-                <a:solidFill>
-                  <a:srgbClr val="1F7A6E"/>
-                </a:solidFill>
-                <a:latin typeface="Calibri"/>
-              </a:rPr>
-              <a:t>M4</a:t>
-            </a:r>
-          </a:p>
-          <a:p>
-            <a:pPr>
-              <a:spcBef>
-                <a:spcPts val="400"/>
-              </a:spcBef>
-            </a:pPr>
-            <a:r>
-              <a:rPr sz="1200" b="0">
-                <a:solidFill>
-                  <a:srgbClr val="1A1F24"/>
-                </a:solidFill>
-                <a:latin typeface="Calibri"/>
-              </a:rPr>
-              <a:t>Policy RAG</a:t>
-            </a:r>
-          </a:p>
-          <a:p>
-            <a:pPr>
-              <a:spcBef>
-                <a:spcPts val="400"/>
-              </a:spcBef>
-            </a:pPr>
-            <a:r>
-              <a:rPr sz="1200" b="0">
-                <a:solidFill>
-                  <a:srgbClr val="1A1F24"/>
-                </a:solidFill>
-                <a:latin typeface="Calibri"/>
-              </a:rPr>
-              <a:t/>
-            </a:r>
-          </a:p>
-          <a:p>
-            <a:pPr>
-              <a:spcBef>
-                <a:spcPts val="400"/>
-              </a:spcBef>
-            </a:pPr>
-            <a:r>
-              <a:rPr sz="1200" b="0">
-                <a:solidFill>
-                  <a:srgbClr val="1A1F24"/>
-                </a:solidFill>
-                <a:latin typeface="Calibri"/>
-              </a:rPr>
-              <a:t>PDFs + 15Q after CP1</a:t>
-            </a:r>
-          </a:p>
-        </p:txBody>
-      </p:sp>
-      <p:sp>
-        <p:nvSpPr>
-          <p:cNvPr id="9" name="Rounded Rectangle 8"/>
-          <p:cNvSpPr/>
-          <p:nvPr/>
-        </p:nvSpPr>
-        <p:spPr>
-          <a:xfrm>
-            <a:off x="9646920" y="1554480"/>
-            <a:ext cx="2148840" cy="3840480"/>
-          </a:xfrm>
-          <a:prstGeom prst="roundRect">
-            <a:avLst>
-              <a:gd name="adj" fmla="val 8000"/>
-            </a:avLst>
-          </a:prstGeom>
-          <a:solidFill>
-            <a:srgbClr val="FFFFFF"/>
-          </a:solidFill>
-          <a:ln>
-            <a:solidFill>
-              <a:srgbClr val="E7EEEC"/>
-            </a:solidFill>
-          </a:ln>
-        </p:spPr>
-        <p:style>
-          <a:lnRef idx="1">
-            <a:schemeClr val="accent1"/>
-          </a:lnRef>
-          <a:fillRef idx="3">
-            <a:schemeClr val="accent1"/>
-          </a:fillRef>
-          <a:effectRef idx="2">
-            <a:schemeClr val="accent1"/>
-          </a:effectRef>
-          <a:fontRef idx="minor">
-            <a:schemeClr val="lt1"/>
-          </a:fontRef>
-        </p:style>
-        <p:txBody>
-          <a:bodyPr rtlCol="0" anchor="ctr" wrap="square" lIns="164592" rIns="164592" tIns="128016"/>
-          <a:lstStyle/>
-          <a:p>
-            <a:pPr algn="ctr"/>
-            <a:r>
-              <a:rPr sz="1400" b="1">
-                <a:solidFill>
-                  <a:srgbClr val="1F7A6E"/>
-                </a:solidFill>
-                <a:latin typeface="Calibri"/>
-              </a:rPr>
-              <a:t>M5</a:t>
-            </a:r>
-          </a:p>
-          <a:p>
-            <a:pPr>
-              <a:spcBef>
-                <a:spcPts val="400"/>
-              </a:spcBef>
-            </a:pPr>
-            <a:r>
-              <a:rPr sz="1200" b="0">
-                <a:solidFill>
-                  <a:srgbClr val="1A1F24"/>
-                </a:solidFill>
-                <a:latin typeface="Calibri"/>
-              </a:rPr>
-              <a:t>Deck + rehearsal</a:t>
-            </a:r>
-          </a:p>
-          <a:p>
-            <a:pPr>
-              <a:spcBef>
-                <a:spcPts val="400"/>
-              </a:spcBef>
-            </a:pPr>
-            <a:r>
-              <a:rPr sz="1200" b="0">
-                <a:solidFill>
-                  <a:srgbClr val="1A1F24"/>
-                </a:solidFill>
-                <a:latin typeface="Calibri"/>
-              </a:rPr>
-              <a:t/>
-            </a:r>
-          </a:p>
-          <a:p>
-            <a:pPr>
-              <a:spcBef>
-                <a:spcPts val="400"/>
-              </a:spcBef>
-            </a:pPr>
-            <a:r>
-              <a:rPr sz="1200" b="0">
-                <a:solidFill>
-                  <a:srgbClr val="1A1F24"/>
-                </a:solidFill>
-                <a:latin typeface="Calibri"/>
-              </a:rPr>
-              <a:t>Slides, rubric checklist</a:t>
-            </a:r>
-          </a:p>
-        </p:txBody>
-      </p:sp>
-      <p:sp>
-        <p:nvSpPr>
-          <p:cNvPr id="10" name="TextBox 9"/>
+              <a:t>What lives outside the notebook but supports the same story</a:t>
+            </a:r>
+          </a:p>
+        </p:txBody>
+      </p:sp>
+      <p:sp>
+        <p:nvSpPr>
+          <p:cNvPr id="5" name="TextBox 4"/>
+          <p:cNvSpPr txBox="1"/>
+          <p:nvPr/>
+        </p:nvSpPr>
+        <p:spPr>
+          <a:xfrm>
+            <a:off x="502920" y="1371600"/>
+            <a:ext cx="11155680" cy="5029200"/>
+          </a:xfrm>
+          <a:prstGeom prst="rect">
+            <a:avLst/>
+          </a:prstGeom>
+          <a:noFill/>
+        </p:spPr>
+        <p:txBody>
+          <a:bodyPr wrap="square">
+            <a:spAutoFit/>
+          </a:bodyPr>
+          <a:lstStyle/>
+          <a:p>
+            <a:pPr>
+              <a:spcAft>
+                <a:spcPts val="800"/>
+              </a:spcAft>
+            </a:pPr>
+            <a:r>
+              <a:rPr sz="1600" b="0">
+                <a:solidFill>
+                  <a:srgbClr val="1A1F24"/>
+                </a:solidFill>
+                <a:latin typeface="Calibri"/>
+              </a:rPr>
+              <a:t>app/inference.py — mirrors generate_from_image for the standalone Gradio app</a:t>
+            </a:r>
+          </a:p>
+          <a:p>
+            <a:pPr>
+              <a:spcAft>
+                <a:spcPts val="800"/>
+              </a:spcAft>
+            </a:pPr>
+            <a:r>
+              <a:rPr sz="1600" b="0">
+                <a:solidFill>
+                  <a:srgbClr val="1A1F24"/>
+                </a:solidFill>
+                <a:latin typeface="Calibri"/>
+              </a:rPr>
+              <a:t>app/gradio_app.py — dummy by default · --no-dummy with adapter path</a:t>
+            </a:r>
+          </a:p>
+          <a:p>
+            <a:pPr>
+              <a:spcAft>
+                <a:spcPts val="800"/>
+              </a:spcAft>
+            </a:pPr>
+            <a:r>
+              <a:rPr sz="1600" b="0">
+                <a:solidFill>
+                  <a:srgbClr val="1A1F24"/>
+                </a:solidFill>
+                <a:latin typeface="Calibri"/>
+              </a:rPr>
+              <a:t>scripts/score.py · validate_notebook.py · demo_pipeline.py · freeze_eval_sample.py</a:t>
+            </a:r>
+          </a:p>
+          <a:p>
+            <a:pPr>
+              <a:spcAft>
+                <a:spcPts val="800"/>
+              </a:spcAft>
+            </a:pPr>
+            <a:r>
+              <a:rPr sz="1600" b="0">
+                <a:solidFill>
+                  <a:srgbClr val="1A1F24"/>
+                </a:solidFill>
+                <a:latin typeface="Calibri"/>
+              </a:rPr>
+              <a:t>tests/ — 40 standard-library tests · bash scripts/check.sh = CI</a:t>
+            </a:r>
+          </a:p>
+          <a:p>
+            <a:pPr>
+              <a:spcAft>
+                <a:spcPts val="800"/>
+              </a:spcAft>
+            </a:pPr>
+            <a:r>
+              <a:rPr sz="1600" b="0">
+                <a:solidFill>
+                  <a:srgbClr val="1A1F24"/>
+                </a:solidFill>
+                <a:latin typeface="Calibri"/>
+              </a:rPr>
+              <a:t>dev = integration branch · main = submitted baseline</a:t>
+            </a:r>
+          </a:p>
+          <a:p>
+            <a:pPr>
+              <a:spcAft>
+                <a:spcPts val="800"/>
+              </a:spcAft>
+            </a:pPr>
+            <a:r>
+              <a:rPr sz="1600" b="0">
+                <a:solidFill>
+                  <a:srgbClr val="1A1F24"/>
+                </a:solidFill>
+                <a:latin typeface="Calibri"/>
+              </a:rPr>
+              <a:t>GPU work stays in Colab; local checks stay CPU-only</a:t>
+            </a:r>
+          </a:p>
+        </p:txBody>
+      </p:sp>
+      <p:sp>
+        <p:nvSpPr>
+          <p:cNvPr id="6" name="TextBox 5"/>
           <p:cNvSpPr txBox="1"/>
           <p:nvPr/>
         </p:nvSpPr>
@@ -10438,7 +10065,7 @@
       </p:sp>
       <p:sp>
         <p:nvSpPr>
-          <p:cNvPr id="11" name="TextBox 10"/>
+          <p:cNvPr id="7" name="TextBox 6"/>
           <p:cNvSpPr txBox="1"/>
           <p:nvPr/>
         </p:nvSpPr>
@@ -10466,7 +10093,7 @@
                 </a:solidFill>
                 <a:latin typeface="Calibri"/>
               </a:rPr>
-              <a:t>25 / 28</a:t>
+              <a:t>25 / 29</a:t>
             </a:r>
           </a:p>
         </p:txBody>
@@ -10604,7 +10231,7 @@
                 </a:solidFill>
                 <a:latin typeface="Georgia"/>
               </a:rPr>
-              <a:t>Definition of done (rubric checklist)</a:t>
+              <a:t>Team ownership (Hack Day 3B)</a:t>
             </a:r>
           </a:p>
           <a:p>
@@ -10620,149 +10247,534 @@
                 </a:solidFill>
                 <a:latin typeface="Calibri"/>
               </a:rPr>
-              <a:t>Tick these before the final rehearsal</a:t>
-            </a:r>
-          </a:p>
-        </p:txBody>
-      </p:sp>
-      <p:sp>
-        <p:nvSpPr>
-          <p:cNvPr id="5" name="TextBox 4"/>
-          <p:cNvSpPr txBox="1"/>
-          <p:nvPr/>
-        </p:nvSpPr>
-        <p:spPr>
-          <a:xfrm>
-            <a:off x="502920" y="1371600"/>
-            <a:ext cx="11155680" cy="5029200"/>
-          </a:xfrm>
-          <a:prstGeom prst="rect">
-            <a:avLst/>
-          </a:prstGeom>
-          <a:noFill/>
-        </p:spPr>
-        <p:txBody>
-          <a:bodyPr wrap="square">
-            <a:spAutoFit/>
-          </a:bodyPr>
-          <a:lstStyle/>
-          <a:p>
-            <a:pPr>
-              <a:spcAft>
-                <a:spcPts val="800"/>
-              </a:spcAft>
-            </a:pPr>
-            <a:r>
-              <a:rPr sz="1600" b="0">
-                <a:solidFill>
-                  <a:srgbClr val="1A1F24"/>
-                </a:solidFill>
-                <a:latin typeface="Calibri"/>
-              </a:rPr>
-              <a:t>Fine-tuned model with settings documented (steps, LR, rank, image size, subset)</a:t>
-            </a:r>
-          </a:p>
-          <a:p>
-            <a:pPr>
-              <a:spcAft>
-                <a:spcPts val="800"/>
-              </a:spcAft>
-            </a:pPr>
-            <a:r>
-              <a:rPr sz="1600" b="0">
-                <a:solidFill>
-                  <a:srgbClr val="1A1F24"/>
-                </a:solidFill>
-                <a:latin typeface="Calibri"/>
-              </a:rPr>
-              <a:t>Dataset description: source, 626/361, fields, filtering, frozen eval sample</a:t>
-            </a:r>
-          </a:p>
-          <a:p>
-            <a:pPr>
-              <a:spcAft>
-                <a:spcPts val="800"/>
-              </a:spcAft>
-            </a:pPr>
-            <a:r>
-              <a:rPr sz="1600" b="0">
-                <a:solidFill>
-                  <a:srgbClr val="1A1F24"/>
-                </a:solidFill>
-                <a:latin typeface="Calibri"/>
-              </a:rPr>
-              <a:t>Comparative analysis on the same receipts (JSON + four fields + address F1)</a:t>
-            </a:r>
-          </a:p>
-          <a:p>
-            <a:pPr>
-              <a:spcAft>
-                <a:spcPts val="800"/>
-              </a:spcAft>
-            </a:pPr>
-            <a:r>
-              <a:rPr sz="1600" b="0">
-                <a:solidFill>
-                  <a:srgbClr val="1A1F24"/>
-                </a:solidFill>
-                <a:latin typeface="Calibri"/>
-              </a:rPr>
-              <a:t>Working app demonstrated live (upload → extract → edit → claim draft)</a:t>
-            </a:r>
-          </a:p>
-          <a:p>
-            <a:pPr>
-              <a:spcAft>
-                <a:spcPts val="800"/>
-              </a:spcAft>
-            </a:pPr>
-            <a:r>
-              <a:rPr sz="1600" b="0">
-                <a:solidFill>
-                  <a:srgbClr val="1A1F24"/>
-                </a:solidFill>
-                <a:latin typeface="Calibri"/>
-              </a:rPr>
-              <a:t>Discussion of where fine-tuning helped / did not / why</a:t>
-            </a:r>
-          </a:p>
-          <a:p>
-            <a:pPr>
-              <a:spcAft>
-                <a:spcPts val="800"/>
-              </a:spcAft>
-            </a:pPr>
-            <a:r>
-              <a:rPr sz="1600" b="0">
-                <a:solidFill>
-                  <a:srgbClr val="1A1F24"/>
-                </a:solidFill>
-                <a:latin typeface="Calibri"/>
-              </a:rPr>
-              <a:t>Backup video + screenshots if live demo fails</a:t>
-            </a:r>
-          </a:p>
-          <a:p>
-            <a:pPr>
-              <a:spcAft>
-                <a:spcPts val="800"/>
-              </a:spcAft>
-            </a:pPr>
-            <a:r>
-              <a:rPr sz="1600" b="0">
-                <a:solidFill>
-                  <a:srgbClr val="1A1F24"/>
-                </a:solidFill>
-                <a:latin typeface="Calibri"/>
-              </a:rPr>
-              <a:t>Bonus only if green: policy RAG with citations, refusal, 15-question test</a:t>
-            </a:r>
-          </a:p>
-        </p:txBody>
-      </p:sp>
-      <p:sp>
-        <p:nvSpPr>
-          <p:cNvPr id="6" name="TextBox 5"/>
+              <a:t>Only M1 edits the shared notebook; others use SCRATCH</a:t>
+            </a:r>
+          </a:p>
+        </p:txBody>
+      </p:sp>
+      <p:sp>
+        <p:nvSpPr>
+          <p:cNvPr id="5" name="Rounded Rectangle 4"/>
+          <p:cNvSpPr/>
+          <p:nvPr/>
+        </p:nvSpPr>
+        <p:spPr>
+          <a:xfrm>
+            <a:off x="502920" y="1554480"/>
+            <a:ext cx="2148840" cy="3840480"/>
+          </a:xfrm>
+          <a:prstGeom prst="roundRect">
+            <a:avLst>
+              <a:gd name="adj" fmla="val 8000"/>
+            </a:avLst>
+          </a:prstGeom>
+          <a:solidFill>
+            <a:srgbClr val="FFFFFF"/>
+          </a:solidFill>
+          <a:ln>
+            <a:solidFill>
+              <a:srgbClr val="E7EEEC"/>
+            </a:solidFill>
+          </a:ln>
+        </p:spPr>
+        <p:style>
+          <a:lnRef idx="1">
+            <a:schemeClr val="accent1"/>
+          </a:lnRef>
+          <a:fillRef idx="3">
+            <a:schemeClr val="accent1"/>
+          </a:fillRef>
+          <a:effectRef idx="2">
+            <a:schemeClr val="accent1"/>
+          </a:effectRef>
+          <a:fontRef idx="minor">
+            <a:schemeClr val="lt1"/>
+          </a:fontRef>
+        </p:style>
+        <p:txBody>
+          <a:bodyPr rtlCol="0" anchor="ctr" wrap="square" lIns="164592" rIns="164592" tIns="128016"/>
+          <a:lstStyle/>
+          <a:p>
+            <a:pPr algn="ctr"/>
+            <a:r>
+              <a:rPr sz="1400" b="1">
+                <a:solidFill>
+                  <a:srgbClr val="1F7A6E"/>
+                </a:solidFill>
+                <a:latin typeface="Calibri"/>
+              </a:rPr>
+              <a:t>M1</a:t>
+            </a:r>
+          </a:p>
+          <a:p>
+            <a:pPr>
+              <a:spcBef>
+                <a:spcPts val="400"/>
+              </a:spcBef>
+            </a:pPr>
+            <a:r>
+              <a:rPr sz="1200" b="0">
+                <a:solidFill>
+                  <a:srgbClr val="1A1F24"/>
+                </a:solidFill>
+                <a:latin typeface="Calibri"/>
+              </a:rPr>
+              <a:t>Notebook + fine-tune</a:t>
+            </a:r>
+          </a:p>
+          <a:p>
+            <a:pPr>
+              <a:spcBef>
+                <a:spcPts val="400"/>
+              </a:spcBef>
+            </a:pPr>
+            <a:r>
+              <a:rPr sz="1200" b="0">
+                <a:solidFill>
+                  <a:srgbClr val="1A1F24"/>
+                </a:solidFill>
+                <a:latin typeface="Calibri"/>
+              </a:rPr>
+              <a:t/>
+            </a:r>
+          </a:p>
+          <a:p>
+            <a:pPr>
+              <a:spcBef>
+                <a:spcPts val="400"/>
+              </a:spcBef>
+            </a:pPr>
+            <a:r>
+              <a:rPr sz="1200" b="0">
+                <a:solidFill>
+                  <a:srgbClr val="1A1F24"/>
+                </a:solidFill>
+                <a:latin typeface="Calibri"/>
+              </a:rPr>
+              <a:t>Colab run, adapters, smoke gate</a:t>
+            </a:r>
+          </a:p>
+        </p:txBody>
+      </p:sp>
+      <p:sp>
+        <p:nvSpPr>
+          <p:cNvPr id="6" name="Rounded Rectangle 5"/>
+          <p:cNvSpPr/>
+          <p:nvPr/>
+        </p:nvSpPr>
+        <p:spPr>
+          <a:xfrm>
+            <a:off x="2788920" y="1554480"/>
+            <a:ext cx="2148840" cy="3840480"/>
+          </a:xfrm>
+          <a:prstGeom prst="roundRect">
+            <a:avLst>
+              <a:gd name="adj" fmla="val 8000"/>
+            </a:avLst>
+          </a:prstGeom>
+          <a:solidFill>
+            <a:srgbClr val="FFFFFF"/>
+          </a:solidFill>
+          <a:ln>
+            <a:solidFill>
+              <a:srgbClr val="E7EEEC"/>
+            </a:solidFill>
+          </a:ln>
+        </p:spPr>
+        <p:style>
+          <a:lnRef idx="1">
+            <a:schemeClr val="accent1"/>
+          </a:lnRef>
+          <a:fillRef idx="3">
+            <a:schemeClr val="accent1"/>
+          </a:fillRef>
+          <a:effectRef idx="2">
+            <a:schemeClr val="accent1"/>
+          </a:effectRef>
+          <a:fontRef idx="minor">
+            <a:schemeClr val="lt1"/>
+          </a:fontRef>
+        </p:style>
+        <p:txBody>
+          <a:bodyPr rtlCol="0" anchor="ctr" wrap="square" lIns="164592" rIns="164592" tIns="128016"/>
+          <a:lstStyle/>
+          <a:p>
+            <a:pPr algn="ctr"/>
+            <a:r>
+              <a:rPr sz="1400" b="1">
+                <a:solidFill>
+                  <a:srgbClr val="1F7A6E"/>
+                </a:solidFill>
+                <a:latin typeface="Calibri"/>
+              </a:rPr>
+              <a:t>M2</a:t>
+            </a:r>
+          </a:p>
+          <a:p>
+            <a:pPr>
+              <a:spcBef>
+                <a:spcPts val="400"/>
+              </a:spcBef>
+            </a:pPr>
+            <a:r>
+              <a:rPr sz="1200" b="0">
+                <a:solidFill>
+                  <a:srgbClr val="1A1F24"/>
+                </a:solidFill>
+                <a:latin typeface="Calibri"/>
+              </a:rPr>
+              <a:t>Eval + metrics</a:t>
+            </a:r>
+          </a:p>
+          <a:p>
+            <a:pPr>
+              <a:spcBef>
+                <a:spcPts val="400"/>
+              </a:spcBef>
+            </a:pPr>
+            <a:r>
+              <a:rPr sz="1200" b="0">
+                <a:solidFill>
+                  <a:srgbClr val="1A1F24"/>
+                </a:solidFill>
+                <a:latin typeface="Calibri"/>
+              </a:rPr>
+              <a:t/>
+            </a:r>
+          </a:p>
+          <a:p>
+            <a:pPr>
+              <a:spcBef>
+                <a:spcPts val="400"/>
+              </a:spcBef>
+            </a:pPr>
+            <a:r>
+              <a:rPr sz="1200" b="0">
+                <a:solidFill>
+                  <a:srgbClr val="1A1F24"/>
+                </a:solidFill>
+                <a:latin typeface="Calibri"/>
+              </a:rPr>
+              <a:t>Frozen keys, comparison, failures</a:t>
+            </a:r>
+          </a:p>
+        </p:txBody>
+      </p:sp>
+      <p:sp>
+        <p:nvSpPr>
+          <p:cNvPr id="7" name="Rounded Rectangle 6"/>
+          <p:cNvSpPr/>
+          <p:nvPr/>
+        </p:nvSpPr>
+        <p:spPr>
+          <a:xfrm>
+            <a:off x="5074920" y="1554480"/>
+            <a:ext cx="2148840" cy="3840480"/>
+          </a:xfrm>
+          <a:prstGeom prst="roundRect">
+            <a:avLst>
+              <a:gd name="adj" fmla="val 8000"/>
+            </a:avLst>
+          </a:prstGeom>
+          <a:solidFill>
+            <a:srgbClr val="FFFFFF"/>
+          </a:solidFill>
+          <a:ln>
+            <a:solidFill>
+              <a:srgbClr val="E7EEEC"/>
+            </a:solidFill>
+          </a:ln>
+        </p:spPr>
+        <p:style>
+          <a:lnRef idx="1">
+            <a:schemeClr val="accent1"/>
+          </a:lnRef>
+          <a:fillRef idx="3">
+            <a:schemeClr val="accent1"/>
+          </a:fillRef>
+          <a:effectRef idx="2">
+            <a:schemeClr val="accent1"/>
+          </a:effectRef>
+          <a:fontRef idx="minor">
+            <a:schemeClr val="lt1"/>
+          </a:fontRef>
+        </p:style>
+        <p:txBody>
+          <a:bodyPr rtlCol="0" anchor="ctr" wrap="square" lIns="164592" rIns="164592" tIns="128016"/>
+          <a:lstStyle/>
+          <a:p>
+            <a:pPr algn="ctr"/>
+            <a:r>
+              <a:rPr sz="1400" b="1">
+                <a:solidFill>
+                  <a:srgbClr val="1F7A6E"/>
+                </a:solidFill>
+                <a:latin typeface="Calibri"/>
+              </a:rPr>
+              <a:t>M3</a:t>
+            </a:r>
+          </a:p>
+          <a:p>
+            <a:pPr>
+              <a:spcBef>
+                <a:spcPts val="400"/>
+              </a:spcBef>
+            </a:pPr>
+            <a:r>
+              <a:rPr sz="1200" b="0">
+                <a:solidFill>
+                  <a:srgbClr val="1A1F24"/>
+                </a:solidFill>
+                <a:latin typeface="Calibri"/>
+              </a:rPr>
+              <a:t>App + demo</a:t>
+            </a:r>
+          </a:p>
+          <a:p>
+            <a:pPr>
+              <a:spcBef>
+                <a:spcPts val="400"/>
+              </a:spcBef>
+            </a:pPr>
+            <a:r>
+              <a:rPr sz="1200" b="0">
+                <a:solidFill>
+                  <a:srgbClr val="1A1F24"/>
+                </a:solidFill>
+                <a:latin typeface="Calibri"/>
+              </a:rPr>
+              <a:t/>
+            </a:r>
+          </a:p>
+          <a:p>
+            <a:pPr>
+              <a:spcBef>
+                <a:spcPts val="400"/>
+              </a:spcBef>
+            </a:pPr>
+            <a:r>
+              <a:rPr sz="1200" b="0">
+                <a:solidFill>
+                  <a:srgbClr val="1A1F24"/>
+                </a:solidFill>
+                <a:latin typeface="Calibri"/>
+              </a:rPr>
+              <a:t>Gradio, screenshots, backup clip</a:t>
+            </a:r>
+          </a:p>
+        </p:txBody>
+      </p:sp>
+      <p:sp>
+        <p:nvSpPr>
+          <p:cNvPr id="8" name="Rounded Rectangle 7"/>
+          <p:cNvSpPr/>
+          <p:nvPr/>
+        </p:nvSpPr>
+        <p:spPr>
+          <a:xfrm>
+            <a:off x="7360920" y="1554480"/>
+            <a:ext cx="2148840" cy="3840480"/>
+          </a:xfrm>
+          <a:prstGeom prst="roundRect">
+            <a:avLst>
+              <a:gd name="adj" fmla="val 8000"/>
+            </a:avLst>
+          </a:prstGeom>
+          <a:solidFill>
+            <a:srgbClr val="FFFFFF"/>
+          </a:solidFill>
+          <a:ln>
+            <a:solidFill>
+              <a:srgbClr val="E7EEEC"/>
+            </a:solidFill>
+          </a:ln>
+        </p:spPr>
+        <p:style>
+          <a:lnRef idx="1">
+            <a:schemeClr val="accent1"/>
+          </a:lnRef>
+          <a:fillRef idx="3">
+            <a:schemeClr val="accent1"/>
+          </a:fillRef>
+          <a:effectRef idx="2">
+            <a:schemeClr val="accent1"/>
+          </a:effectRef>
+          <a:fontRef idx="minor">
+            <a:schemeClr val="lt1"/>
+          </a:fontRef>
+        </p:style>
+        <p:txBody>
+          <a:bodyPr rtlCol="0" anchor="ctr" wrap="square" lIns="164592" rIns="164592" tIns="128016"/>
+          <a:lstStyle/>
+          <a:p>
+            <a:pPr algn="ctr"/>
+            <a:r>
+              <a:rPr sz="1400" b="1">
+                <a:solidFill>
+                  <a:srgbClr val="1F7A6E"/>
+                </a:solidFill>
+                <a:latin typeface="Calibri"/>
+              </a:rPr>
+              <a:t>M4</a:t>
+            </a:r>
+          </a:p>
+          <a:p>
+            <a:pPr>
+              <a:spcBef>
+                <a:spcPts val="400"/>
+              </a:spcBef>
+            </a:pPr>
+            <a:r>
+              <a:rPr sz="1200" b="0">
+                <a:solidFill>
+                  <a:srgbClr val="1A1F24"/>
+                </a:solidFill>
+                <a:latin typeface="Calibri"/>
+              </a:rPr>
+              <a:t>Policy RAG</a:t>
+            </a:r>
+          </a:p>
+          <a:p>
+            <a:pPr>
+              <a:spcBef>
+                <a:spcPts val="400"/>
+              </a:spcBef>
+            </a:pPr>
+            <a:r>
+              <a:rPr sz="1200" b="0">
+                <a:solidFill>
+                  <a:srgbClr val="1A1F24"/>
+                </a:solidFill>
+                <a:latin typeface="Calibri"/>
+              </a:rPr>
+              <a:t/>
+            </a:r>
+          </a:p>
+          <a:p>
+            <a:pPr>
+              <a:spcBef>
+                <a:spcPts val="400"/>
+              </a:spcBef>
+            </a:pPr>
+            <a:r>
+              <a:rPr sz="1200" b="0">
+                <a:solidFill>
+                  <a:srgbClr val="1A1F24"/>
+                </a:solidFill>
+                <a:latin typeface="Calibri"/>
+              </a:rPr>
+              <a:t>PDFs + 15Q after CP1</a:t>
+            </a:r>
+          </a:p>
+        </p:txBody>
+      </p:sp>
+      <p:sp>
+        <p:nvSpPr>
+          <p:cNvPr id="9" name="Rounded Rectangle 8"/>
+          <p:cNvSpPr/>
+          <p:nvPr/>
+        </p:nvSpPr>
+        <p:spPr>
+          <a:xfrm>
+            <a:off x="9646920" y="1554480"/>
+            <a:ext cx="2148840" cy="3840480"/>
+          </a:xfrm>
+          <a:prstGeom prst="roundRect">
+            <a:avLst>
+              <a:gd name="adj" fmla="val 8000"/>
+            </a:avLst>
+          </a:prstGeom>
+          <a:solidFill>
+            <a:srgbClr val="FFFFFF"/>
+          </a:solidFill>
+          <a:ln>
+            <a:solidFill>
+              <a:srgbClr val="E7EEEC"/>
+            </a:solidFill>
+          </a:ln>
+        </p:spPr>
+        <p:style>
+          <a:lnRef idx="1">
+            <a:schemeClr val="accent1"/>
+          </a:lnRef>
+          <a:fillRef idx="3">
+            <a:schemeClr val="accent1"/>
+          </a:fillRef>
+          <a:effectRef idx="2">
+            <a:schemeClr val="accent1"/>
+          </a:effectRef>
+          <a:fontRef idx="minor">
+            <a:schemeClr val="lt1"/>
+          </a:fontRef>
+        </p:style>
+        <p:txBody>
+          <a:bodyPr rtlCol="0" anchor="ctr" wrap="square" lIns="164592" rIns="164592" tIns="128016"/>
+          <a:lstStyle/>
+          <a:p>
+            <a:pPr algn="ctr"/>
+            <a:r>
+              <a:rPr sz="1400" b="1">
+                <a:solidFill>
+                  <a:srgbClr val="1F7A6E"/>
+                </a:solidFill>
+                <a:latin typeface="Calibri"/>
+              </a:rPr>
+              <a:t>M5</a:t>
+            </a:r>
+          </a:p>
+          <a:p>
+            <a:pPr>
+              <a:spcBef>
+                <a:spcPts val="400"/>
+              </a:spcBef>
+            </a:pPr>
+            <a:r>
+              <a:rPr sz="1200" b="0">
+                <a:solidFill>
+                  <a:srgbClr val="1A1F24"/>
+                </a:solidFill>
+                <a:latin typeface="Calibri"/>
+              </a:rPr>
+              <a:t>Deck + rehearsal</a:t>
+            </a:r>
+          </a:p>
+          <a:p>
+            <a:pPr>
+              <a:spcBef>
+                <a:spcPts val="400"/>
+              </a:spcBef>
+            </a:pPr>
+            <a:r>
+              <a:rPr sz="1200" b="0">
+                <a:solidFill>
+                  <a:srgbClr val="1A1F24"/>
+                </a:solidFill>
+                <a:latin typeface="Calibri"/>
+              </a:rPr>
+              <a:t/>
+            </a:r>
+          </a:p>
+          <a:p>
+            <a:pPr>
+              <a:spcBef>
+                <a:spcPts val="400"/>
+              </a:spcBef>
+            </a:pPr>
+            <a:r>
+              <a:rPr sz="1200" b="0">
+                <a:solidFill>
+                  <a:srgbClr val="1A1F24"/>
+                </a:solidFill>
+                <a:latin typeface="Calibri"/>
+              </a:rPr>
+              <a:t>Slides, rubric checklist</a:t>
+            </a:r>
+          </a:p>
+        </p:txBody>
+      </p:sp>
+      <p:sp>
+        <p:nvSpPr>
+          <p:cNvPr id="10" name="TextBox 9"/>
           <p:cNvSpPr txBox="1"/>
           <p:nvPr/>
         </p:nvSpPr>
@@ -10796,7 +10808,7 @@
       </p:sp>
       <p:sp>
         <p:nvSpPr>
-          <p:cNvPr id="7" name="TextBox 6"/>
+          <p:cNvPr id="11" name="TextBox 10"/>
           <p:cNvSpPr txBox="1"/>
           <p:nvPr/>
         </p:nvSpPr>
@@ -10824,7 +10836,7 @@
                 </a:solidFill>
                 <a:latin typeface="Calibri"/>
               </a:rPr>
-              <a:t>26 / 28</a:t>
+              <a:t>26 / 29</a:t>
             </a:r>
           </a:p>
         </p:txBody>
@@ -10962,7 +10974,7 @@
                 </a:solidFill>
                 <a:latin typeface="Georgia"/>
               </a:rPr>
-              <a:t>Immediate next steps for M1</a:t>
+              <a:t>Definition of done (rubric checklist)</a:t>
             </a:r>
           </a:p>
           <a:p>
@@ -10978,7 +10990,7 @@
                 </a:solidFill>
                 <a:latin typeface="Calibri"/>
               </a:rPr>
-              <a:t>Where the notebook run stands operationally</a:t>
+              <a:t>Tick these before the final rehearsal</a:t>
             </a:r>
           </a:p>
         </p:txBody>
@@ -11017,7 +11029,7 @@
                 </a:solidFill>
                 <a:latin typeface="Calibri"/>
               </a:rPr>
-              <a:t>Disconnect and delete the Colab runtime after any RAM crash</a:t>
+              <a:t>Fine-tuned model with settings documented (steps, LR, rank, image size, subset)</a:t>
             </a:r>
           </a:p>
           <a:p>
@@ -11033,7 +11045,7 @@
                 </a:solidFill>
                 <a:latin typeface="Calibri"/>
               </a:rPr>
-              <a:t>Upload the patched notebooks/campusclaim_3b.ipynb</a:t>
+              <a:t>Dataset description: source, 626/361, fields, filtering, frozen eval sample</a:t>
             </a:r>
           </a:p>
           <a:p>
@@ -11049,7 +11061,7 @@
                 </a:solidFill>
                 <a:latin typeface="Calibri"/>
               </a:rPr>
-              <a:t>Run install → GPU check → model → data → conversations → smoke test</a:t>
+              <a:t>Comparative analysis on the same receipts (JSON + four fields + address F1)</a:t>
             </a:r>
           </a:p>
           <a:p>
@@ -11065,7 +11077,7 @@
                 </a:solidFill>
                 <a:latin typeface="Calibri"/>
               </a:rPr>
-              <a:t>Paste smoke output before starting the 100-receipt baseline</a:t>
+              <a:t>Working app demonstrated live (upload → extract → edit → claim draft)</a:t>
             </a:r>
           </a:p>
           <a:p>
@@ -11081,7 +11093,7 @@
                 </a:solidFill>
                 <a:latin typeface="Calibri"/>
               </a:rPr>
-              <a:t>After training: save zip to Drive · run fine-tuned eval · export results/</a:t>
+              <a:t>Discussion of where fine-tuning helped / did not / why</a:t>
             </a:r>
           </a:p>
           <a:p>
@@ -11097,7 +11109,23 @@
                 </a:solidFill>
                 <a:latin typeface="Calibri"/>
               </a:rPr>
-              <a:t>Hand results/ to M2 · fill metrics slide · rehearse the 5-minute script</a:t>
+              <a:t>Backup video + screenshots if live demo fails</a:t>
+            </a:r>
+          </a:p>
+          <a:p>
+            <a:pPr>
+              <a:spcAft>
+                <a:spcPts val="800"/>
+              </a:spcAft>
+            </a:pPr>
+            <a:r>
+              <a:rPr sz="1600" b="0">
+                <a:solidFill>
+                  <a:srgbClr val="1A1F24"/>
+                </a:solidFill>
+                <a:latin typeface="Calibri"/>
+              </a:rPr>
+              <a:t>Bonus only if green: policy RAG with citations, refusal, 15-question test</a:t>
             </a:r>
           </a:p>
         </p:txBody>
@@ -11166,7 +11194,7 @@
                 </a:solidFill>
                 <a:latin typeface="Calibri"/>
               </a:rPr>
-              <a:t>27 / 28</a:t>
+              <a:t>27 / 29</a:t>
             </a:r>
           </a:p>
         </p:txBody>
@@ -11277,6 +11305,348 @@
       </p:sp>
       <p:sp>
         <p:nvSpPr>
+          <p:cNvPr id="4" name="TextBox 3"/>
+          <p:cNvSpPr txBox="1"/>
+          <p:nvPr/>
+        </p:nvSpPr>
+        <p:spPr>
+          <a:xfrm>
+            <a:off x="502920" y="256032"/>
+            <a:ext cx="11155680" cy="1005840"/>
+          </a:xfrm>
+          <a:prstGeom prst="rect">
+            <a:avLst/>
+          </a:prstGeom>
+          <a:noFill/>
+        </p:spPr>
+        <p:txBody>
+          <a:bodyPr wrap="square">
+            <a:spAutoFit/>
+          </a:bodyPr>
+          <a:lstStyle/>
+          <a:p>
+            <a:r>
+              <a:rPr sz="2800" b="1">
+                <a:solidFill>
+                  <a:srgbClr val="0F2C3C"/>
+                </a:solidFill>
+                <a:latin typeface="Georgia"/>
+              </a:rPr>
+              <a:t>Immediate next steps for M1</a:t>
+            </a:r>
+          </a:p>
+          <a:p>
+            <a:pPr>
+              <a:spcBef>
+                <a:spcPts val="600"/>
+              </a:spcBef>
+            </a:pPr>
+            <a:r>
+              <a:rPr sz="1400" b="0">
+                <a:solidFill>
+                  <a:srgbClr val="5A656E"/>
+                </a:solidFill>
+                <a:latin typeface="Calibri"/>
+              </a:rPr>
+              <a:t>Where the notebook run stands operationally</a:t>
+            </a:r>
+          </a:p>
+        </p:txBody>
+      </p:sp>
+      <p:sp>
+        <p:nvSpPr>
+          <p:cNvPr id="5" name="TextBox 4"/>
+          <p:cNvSpPr txBox="1"/>
+          <p:nvPr/>
+        </p:nvSpPr>
+        <p:spPr>
+          <a:xfrm>
+            <a:off x="502920" y="1371600"/>
+            <a:ext cx="11155680" cy="5029200"/>
+          </a:xfrm>
+          <a:prstGeom prst="rect">
+            <a:avLst/>
+          </a:prstGeom>
+          <a:noFill/>
+        </p:spPr>
+        <p:txBody>
+          <a:bodyPr wrap="square">
+            <a:spAutoFit/>
+          </a:bodyPr>
+          <a:lstStyle/>
+          <a:p>
+            <a:pPr>
+              <a:spcAft>
+                <a:spcPts val="800"/>
+              </a:spcAft>
+            </a:pPr>
+            <a:r>
+              <a:rPr sz="1600" b="0">
+                <a:solidFill>
+                  <a:srgbClr val="1A1F24"/>
+                </a:solidFill>
+                <a:latin typeface="Calibri"/>
+              </a:rPr>
+              <a:t>Disconnect and delete the Colab runtime after any RAM crash</a:t>
+            </a:r>
+          </a:p>
+          <a:p>
+            <a:pPr>
+              <a:spcAft>
+                <a:spcPts val="800"/>
+              </a:spcAft>
+            </a:pPr>
+            <a:r>
+              <a:rPr sz="1600" b="0">
+                <a:solidFill>
+                  <a:srgbClr val="1A1F24"/>
+                </a:solidFill>
+                <a:latin typeface="Calibri"/>
+              </a:rPr>
+              <a:t>Upload the patched notebooks/campusclaim_3b.ipynb</a:t>
+            </a:r>
+          </a:p>
+          <a:p>
+            <a:pPr>
+              <a:spcAft>
+                <a:spcPts val="800"/>
+              </a:spcAft>
+            </a:pPr>
+            <a:r>
+              <a:rPr sz="1600" b="0">
+                <a:solidFill>
+                  <a:srgbClr val="1A1F24"/>
+                </a:solidFill>
+                <a:latin typeface="Calibri"/>
+              </a:rPr>
+              <a:t>Run install → GPU check → model → data → conversations → smoke test</a:t>
+            </a:r>
+          </a:p>
+          <a:p>
+            <a:pPr>
+              <a:spcAft>
+                <a:spcPts val="800"/>
+              </a:spcAft>
+            </a:pPr>
+            <a:r>
+              <a:rPr sz="1600" b="0">
+                <a:solidFill>
+                  <a:srgbClr val="1A1F24"/>
+                </a:solidFill>
+                <a:latin typeface="Calibri"/>
+              </a:rPr>
+              <a:t>Paste smoke output before starting the 100-receipt baseline</a:t>
+            </a:r>
+          </a:p>
+          <a:p>
+            <a:pPr>
+              <a:spcAft>
+                <a:spcPts val="800"/>
+              </a:spcAft>
+            </a:pPr>
+            <a:r>
+              <a:rPr sz="1600" b="0">
+                <a:solidFill>
+                  <a:srgbClr val="1A1F24"/>
+                </a:solidFill>
+                <a:latin typeface="Calibri"/>
+              </a:rPr>
+              <a:t>After training: save zip to Drive · run fine-tuned eval · export results/</a:t>
+            </a:r>
+          </a:p>
+          <a:p>
+            <a:pPr>
+              <a:spcAft>
+                <a:spcPts val="800"/>
+              </a:spcAft>
+            </a:pPr>
+            <a:r>
+              <a:rPr sz="1600" b="0">
+                <a:solidFill>
+                  <a:srgbClr val="1A1F24"/>
+                </a:solidFill>
+                <a:latin typeface="Calibri"/>
+              </a:rPr>
+              <a:t>Hand results/ to M2 · fill metrics slide · rehearse the 5-minute script</a:t>
+            </a:r>
+          </a:p>
+        </p:txBody>
+      </p:sp>
+      <p:sp>
+        <p:nvSpPr>
+          <p:cNvPr id="6" name="TextBox 5"/>
+          <p:cNvSpPr txBox="1"/>
+          <p:nvPr/>
+        </p:nvSpPr>
+        <p:spPr>
+          <a:xfrm>
+            <a:off x="502920" y="6446520"/>
+            <a:ext cx="9144000" cy="320040"/>
+          </a:xfrm>
+          <a:prstGeom prst="rect">
+            <a:avLst/>
+          </a:prstGeom>
+          <a:noFill/>
+        </p:spPr>
+        <p:txBody>
+          <a:bodyPr wrap="none">
+            <a:spAutoFit/>
+          </a:bodyPr>
+          <a:lstStyle/>
+          <a:p>
+            <a:r>
+              <a:rPr sz="1000" b="0">
+                <a:solidFill>
+                  <a:srgbClr val="5A656E"/>
+                </a:solidFill>
+                <a:latin typeface="Calibri"/>
+              </a:rPr>
+              <a:t>CampusClaim · Theme 3B · notebooks/campusclaim_3b.ipynb</a:t>
+            </a:r>
+          </a:p>
+        </p:txBody>
+      </p:sp>
+      <p:sp>
+        <p:nvSpPr>
+          <p:cNvPr id="7" name="TextBox 6"/>
+          <p:cNvSpPr txBox="1"/>
+          <p:nvPr/>
+        </p:nvSpPr>
+        <p:spPr>
+          <a:xfrm>
+            <a:off x="10515600" y="6446520"/>
+            <a:ext cx="1280160" cy="320040"/>
+          </a:xfrm>
+          <a:prstGeom prst="rect">
+            <a:avLst/>
+          </a:prstGeom>
+          <a:noFill/>
+        </p:spPr>
+        <p:txBody>
+          <a:bodyPr wrap="none">
+            <a:spAutoFit/>
+          </a:bodyPr>
+          <a:lstStyle/>
+          <a:p>
+            <a:pPr algn="r"/>
+            <a:r>
+              <a:rPr sz="1000" b="0">
+                <a:solidFill>
+                  <a:srgbClr val="5A656E"/>
+                </a:solidFill>
+                <a:latin typeface="Calibri"/>
+              </a:rPr>
+              <a:t>28 / 29</a:t>
+            </a:r>
+          </a:p>
+        </p:txBody>
+      </p:sp>
+    </p:spTree>
+  </p:cSld>
+  <p:clrMapOvr>
+    <a:masterClrMapping/>
+  </p:clrMapOvr>
+</p:sld>
+</file>
+
+<file path=ppt/slides/slide29.xml><?xml version="1.0" encoding="utf-8"?>
+<p:sld xmlns:a="http://schemas.openxmlformats.org/drawingml/2006/main" xmlns:p="http://schemas.openxmlformats.org/presentationml/2006/main" xmlns:r="http://schemas.openxmlformats.org/officeDocument/2006/relationships">
+  <p:cSld>
+    <p:spTree>
+      <p:nvGrpSpPr>
+        <p:cNvPr id="1" name=""/>
+        <p:cNvGrpSpPr/>
+        <p:nvPr/>
+      </p:nvGrpSpPr>
+      <p:grpSpPr/>
+      <p:sp>
+        <p:nvSpPr>
+          <p:cNvPr id="2" name="Rectangle 1"/>
+          <p:cNvSpPr/>
+          <p:nvPr/>
+        </p:nvSpPr>
+        <p:spPr>
+          <a:xfrm>
+            <a:off x="0" y="0"/>
+            <a:ext cx="12191695" cy="6858000"/>
+          </a:xfrm>
+          <a:prstGeom prst="rect">
+            <a:avLst/>
+          </a:prstGeom>
+          <a:solidFill>
+            <a:srgbClr val="F3F6F5"/>
+          </a:solidFill>
+          <a:ln>
+            <a:noFill/>
+          </a:ln>
+        </p:spPr>
+        <p:style>
+          <a:lnRef idx="1">
+            <a:schemeClr val="accent1"/>
+          </a:lnRef>
+          <a:fillRef idx="3">
+            <a:schemeClr val="accent1"/>
+          </a:fillRef>
+          <a:effectRef idx="2">
+            <a:schemeClr val="accent1"/>
+          </a:effectRef>
+          <a:fontRef idx="minor">
+            <a:schemeClr val="lt1"/>
+          </a:fontRef>
+        </p:style>
+        <p:txBody>
+          <a:bodyPr rtlCol="0" anchor="ctr"/>
+          <a:lstStyle/>
+          <a:p>
+            <a:pPr algn="ctr"/>
+          </a:p>
+        </p:txBody>
+      </p:sp>
+      <p:sp>
+        <p:nvSpPr>
+          <p:cNvPr id="3" name="Rectangle 2"/>
+          <p:cNvSpPr/>
+          <p:nvPr/>
+        </p:nvSpPr>
+        <p:spPr>
+          <a:xfrm>
+            <a:off x="0" y="0"/>
+            <a:ext cx="164592" cy="6858000"/>
+          </a:xfrm>
+          <a:prstGeom prst="rect">
+            <a:avLst/>
+          </a:prstGeom>
+          <a:solidFill>
+            <a:srgbClr val="1F7A6E"/>
+          </a:solidFill>
+          <a:ln>
+            <a:noFill/>
+          </a:ln>
+        </p:spPr>
+        <p:style>
+          <a:lnRef idx="1">
+            <a:schemeClr val="accent1"/>
+          </a:lnRef>
+          <a:fillRef idx="3">
+            <a:schemeClr val="accent1"/>
+          </a:fillRef>
+          <a:effectRef idx="2">
+            <a:schemeClr val="accent1"/>
+          </a:effectRef>
+          <a:fontRef idx="minor">
+            <a:schemeClr val="lt1"/>
+          </a:fontRef>
+        </p:style>
+        <p:txBody>
+          <a:bodyPr rtlCol="0" anchor="ctr"/>
+          <a:lstStyle/>
+          <a:p>
+            <a:pPr algn="ctr"/>
+          </a:p>
+        </p:txBody>
+      </p:sp>
+      <p:sp>
+        <p:nvSpPr>
           <p:cNvPr id="4" name="Rectangle 3"/>
           <p:cNvSpPr/>
           <p:nvPr/>
@@ -12011,7 +12381,7 @@
                 </a:solidFill>
                 <a:latin typeface="Calibri"/>
               </a:rPr>
-              <a:t>3 / 28</a:t>
+              <a:t>3 / 29</a:t>
             </a:r>
           </a:p>
         </p:txBody>
@@ -12353,7 +12723,7 @@
                 </a:solidFill>
                 <a:latin typeface="Calibri"/>
               </a:rPr>
-              <a:t>4 / 28</a:t>
+              <a:t>4 / 29</a:t>
             </a:r>
           </a:p>
         </p:txBody>
@@ -13556,7 +13926,7 @@
                 </a:solidFill>
                 <a:latin typeface="Calibri"/>
               </a:rPr>
-              <a:t>5 / 28</a:t>
+              <a:t>5 / 29</a:t>
             </a:r>
           </a:p>
         </p:txBody>
@@ -13930,7 +14300,7 @@
                 </a:solidFill>
                 <a:latin typeface="Calibri"/>
               </a:rPr>
-              <a:t>6 / 28</a:t>
+              <a:t>6 / 29</a:t>
             </a:r>
           </a:p>
         </p:txBody>
@@ -14304,7 +14674,7 @@
                 </a:solidFill>
                 <a:latin typeface="Calibri"/>
               </a:rPr>
-              <a:t>7 / 28</a:t>
+              <a:t>7 / 29</a:t>
             </a:r>
           </a:p>
         </p:txBody>
@@ -14678,7 +15048,7 @@
                 </a:solidFill>
                 <a:latin typeface="Calibri"/>
               </a:rPr>
-              <a:t>8 / 28</a:t>
+              <a:t>8 / 29</a:t>
             </a:r>
           </a:p>
         </p:txBody>
@@ -15036,7 +15406,7 @@
                 </a:solidFill>
                 <a:latin typeface="Calibri"/>
               </a:rPr>
-              <a:t>9 / 28</a:t>
+              <a:t>9 / 29</a:t>
             </a:r>
           </a:p>
         </p:txBody>

</xml_diff>